<commit_message>
Add creative images to the presentation for Domaine Fendri
Replace placeholder images with actual project architecture and configurator flow diagrams in the presentation.

Replit-Commit-Author: Agent
Replit-Commit-Session-Id: bd3f43bf-4228-471a-8ae9-1620799c028d
Replit-Commit-Checkpoint-Type: full_checkpoint
Replit-Commit-Event-Id: da9d94eb-1a67-443c-aaa1-e349de9a27a1
Replit-Commit-Screenshot-Url: https://storage.googleapis.com/screenshot-production-us-central1/360bbbc4-7a04-407d-b768-9ee038e36526/bd3f43bf-4228-471a-8ae9-1620799c028d/sLgw0OU
Replit-Helium-Checkpoint-Created: true
</commit_message>
<xml_diff>
--- a/attached_assets/PFE_Domaine_Fendri_Yessmine_Hsine.pptx
+++ b/attached_assets/PFE_Domaine_Fendri_Yessmine_Hsine.pptx
@@ -9611,33 +9611,6 @@
           </a:ln>
         </p:spPr>
       </p:pic>
-      <p:pic>
-        <p:nvPicPr>
-          <p:cNvPr descr="image.png" id="304" name="Google Shape;304;p23"/>
-          <p:cNvPicPr preferRelativeResize="0"/>
-          <p:nvPr/>
-        </p:nvPicPr>
-        <p:blipFill rotWithShape="1">
-          <a:blip r:embed="rId4">
-            <a:alphaModFix/>
-          </a:blip>
-          <a:srcRect b="0" l="0" r="0" t="0"/>
-          <a:stretch/>
-        </p:blipFill>
-        <p:spPr>
-          <a:xfrm>
-            <a:off x="1714500" y="2309812"/>
-            <a:ext cx="3048000" cy="3048000"/>
-          </a:xfrm>
-          <a:prstGeom prst="rect">
-            <a:avLst/>
-          </a:prstGeom>
-          <a:noFill/>
-          <a:ln>
-            <a:noFill/>
-          </a:ln>
-        </p:spPr>
-      </p:pic>
       <p:sp>
         <p:nvSpPr>
           <p:cNvPr id="305" name="Google Shape;305;p23"/>
@@ -9806,33 +9779,6 @@
           </a:p>
         </p:txBody>
       </p:sp>
-      <p:pic>
-        <p:nvPicPr>
-          <p:cNvPr descr="image.png" id="308" name="Google Shape;308;p23"/>
-          <p:cNvPicPr preferRelativeResize="0"/>
-          <p:nvPr/>
-        </p:nvPicPr>
-        <p:blipFill rotWithShape="1">
-          <a:blip r:embed="rId5">
-            <a:alphaModFix/>
-          </a:blip>
-          <a:srcRect b="0" l="0" r="0" t="0"/>
-          <a:stretch/>
-        </p:blipFill>
-        <p:spPr>
-          <a:xfrm>
-            <a:off x="1752600" y="2347912"/>
-            <a:ext cx="2971800" cy="361950"/>
-          </a:xfrm>
-          <a:prstGeom prst="rect">
-            <a:avLst/>
-          </a:prstGeom>
-          <a:noFill/>
-          <a:ln>
-            <a:noFill/>
-          </a:ln>
-        </p:spPr>
-      </p:pic>
       <p:sp>
         <p:nvSpPr>
           <p:cNvPr id="309" name="Google Shape;309;p23"/>
@@ -10509,6 +10455,30 @@
           </a:p>
         </p:txBody>
       </p:sp>
+      <p:pic>
+        <p:nvPicPr>
+          <p:cNvPr id="321" name="Picture 320" descr="image_1779630408408.png"/>
+          <p:cNvPicPr>
+            <a:picLocks noChangeAspect="1"/>
+          </p:cNvPicPr>
+          <p:nvPr/>
+        </p:nvPicPr>
+        <p:blipFill>
+          <a:blip r:embed="rId6"/>
+          <a:stretch>
+            <a:fillRect/>
+          </a:stretch>
+        </p:blipFill>
+        <p:spPr>
+          <a:xfrm>
+            <a:off x="502920" y="1508760"/>
+            <a:ext cx="11183112" cy="4892040"/>
+          </a:xfrm>
+          <a:prstGeom prst="rect">
+            <a:avLst/>
+          </a:prstGeom>
+        </p:spPr>
+      </p:pic>
     </p:spTree>
   </p:cSld>
   <p:clrMapOvr>
@@ -16465,60 +16435,6 @@
           </a:ln>
         </p:spPr>
       </p:pic>
-      <p:pic>
-        <p:nvPicPr>
-          <p:cNvPr descr="image.png" id="206" name="Google Shape;206;p19"/>
-          <p:cNvPicPr preferRelativeResize="0"/>
-          <p:nvPr/>
-        </p:nvPicPr>
-        <p:blipFill rotWithShape="1">
-          <a:blip r:embed="rId4">
-            <a:alphaModFix/>
-          </a:blip>
-          <a:srcRect b="0" l="0" r="0" t="0"/>
-          <a:stretch/>
-        </p:blipFill>
-        <p:spPr>
-          <a:xfrm>
-            <a:off x="571500" y="2295525"/>
-            <a:ext cx="5429250" cy="3076575"/>
-          </a:xfrm>
-          <a:prstGeom prst="rect">
-            <a:avLst/>
-          </a:prstGeom>
-          <a:noFill/>
-          <a:ln>
-            <a:noFill/>
-          </a:ln>
-        </p:spPr>
-      </p:pic>
-      <p:pic>
-        <p:nvPicPr>
-          <p:cNvPr descr="image.png" id="207" name="Google Shape;207;p19"/>
-          <p:cNvPicPr preferRelativeResize="0"/>
-          <p:nvPr/>
-        </p:nvPicPr>
-        <p:blipFill rotWithShape="1">
-          <a:blip r:embed="rId5">
-            <a:alphaModFix/>
-          </a:blip>
-          <a:srcRect b="0" l="0" r="0" t="0"/>
-          <a:stretch/>
-        </p:blipFill>
-        <p:spPr>
-          <a:xfrm>
-            <a:off x="6191250" y="2295525"/>
-            <a:ext cx="5429250" cy="3076575"/>
-          </a:xfrm>
-          <a:prstGeom prst="rect">
-            <a:avLst/>
-          </a:prstGeom>
-          <a:noFill/>
-          <a:ln>
-            <a:noFill/>
-          </a:ln>
-        </p:spPr>
-      </p:pic>
       <p:sp>
         <p:nvSpPr>
           <p:cNvPr id="208" name="Google Shape;208;p19"/>
@@ -16725,60 +16641,6 @@
           </a:p>
         </p:txBody>
       </p:sp>
-      <p:pic>
-        <p:nvPicPr>
-          <p:cNvPr descr="image.png" id="212" name="Google Shape;212;p19"/>
-          <p:cNvPicPr preferRelativeResize="0"/>
-          <p:nvPr/>
-        </p:nvPicPr>
-        <p:blipFill rotWithShape="1">
-          <a:blip r:embed="rId6">
-            <a:alphaModFix/>
-          </a:blip>
-          <a:srcRect b="0" l="0" r="0" t="0"/>
-          <a:stretch/>
-        </p:blipFill>
-        <p:spPr>
-          <a:xfrm>
-            <a:off x="723900" y="2447925"/>
-            <a:ext cx="5124450" cy="1714500"/>
-          </a:xfrm>
-          <a:prstGeom prst="rect">
-            <a:avLst/>
-          </a:prstGeom>
-          <a:noFill/>
-          <a:ln>
-            <a:noFill/>
-          </a:ln>
-        </p:spPr>
-      </p:pic>
-      <p:pic>
-        <p:nvPicPr>
-          <p:cNvPr descr="image.png" id="213" name="Google Shape;213;p19"/>
-          <p:cNvPicPr preferRelativeResize="0"/>
-          <p:nvPr/>
-        </p:nvPicPr>
-        <p:blipFill rotWithShape="1">
-          <a:blip r:embed="rId7">
-            <a:alphaModFix/>
-          </a:blip>
-          <a:srcRect b="0" l="0" r="0" t="0"/>
-          <a:stretch/>
-        </p:blipFill>
-        <p:spPr>
-          <a:xfrm>
-            <a:off x="6686550" y="2447925"/>
-            <a:ext cx="4438650" cy="180975"/>
-          </a:xfrm>
-          <a:prstGeom prst="rect">
-            <a:avLst/>
-          </a:prstGeom>
-          <a:noFill/>
-          <a:ln>
-            <a:noFill/>
-          </a:ln>
-        </p:spPr>
-      </p:pic>
       <p:sp>
         <p:nvSpPr>
           <p:cNvPr id="214" name="Google Shape;214;p19"/>
@@ -16880,6 +16742,30 @@
           </a:p>
         </p:txBody>
       </p:sp>
+      <p:pic>
+        <p:nvPicPr>
+          <p:cNvPr id="216" name="Picture 215" descr="image_1779630428792.png"/>
+          <p:cNvPicPr>
+            <a:picLocks noChangeAspect="1"/>
+          </p:cNvPicPr>
+          <p:nvPr/>
+        </p:nvPicPr>
+        <p:blipFill>
+          <a:blip r:embed="rId8"/>
+          <a:stretch>
+            <a:fillRect/>
+          </a:stretch>
+        </p:blipFill>
+        <p:spPr>
+          <a:xfrm>
+            <a:off x="502920" y="1508760"/>
+            <a:ext cx="11183112" cy="4892040"/>
+          </a:xfrm>
+          <a:prstGeom prst="rect">
+            <a:avLst/>
+          </a:prstGeom>
+        </p:spPr>
+      </p:pic>
     </p:spTree>
   </p:cSld>
   <p:clrMapOvr>

</xml_diff>

<commit_message>
Add eco-conception performance image to the presentation
Update presentation metadata and add an "Engagement Éco-conception" image to slide 8 of the PFE_Domaine_Fendri_Yessmine_Hsine.pptx file.

Replit-Commit-Author: Agent
Replit-Commit-Session-Id: bd3f43bf-4228-471a-8ae9-1620799c028d
Replit-Commit-Checkpoint-Type: full_checkpoint
Replit-Commit-Event-Id: adc89cd0-0888-45b9-b781-1f1bed5508d7
Replit-Commit-Screenshot-Url: https://storage.googleapis.com/screenshot-production-us-central1/360bbbc4-7a04-407d-b768-9ee038e36526/bd3f43bf-4228-471a-8ae9-1620799c028d/sLgw0OU
Replit-Helium-Checkpoint-Created: true
</commit_message>
<xml_diff>
--- a/attached_assets/PFE_Domaine_Fendri_Yessmine_Hsine.pptx
+++ b/attached_assets/PFE_Domaine_Fendri_Yessmine_Hsine.pptx
@@ -16825,4125 +16825,6 @@
           </a:ln>
         </p:spPr>
       </p:pic>
-      <p:graphicFrame>
-        <p:nvGraphicFramePr>
-          <p:cNvPr id="221" name="Google Shape;221;p20"/>
-          <p:cNvGraphicFramePr/>
-          <p:nvPr/>
-        </p:nvGraphicFramePr>
-        <p:xfrm>
-          <a:off x="571500" y="2847975"/>
-          <a:ext cx="3000000" cy="3000000"/>
-        </p:xfrm>
-        <a:graphic>
-          <a:graphicData uri="http://schemas.openxmlformats.org/drawingml/2006/table">
-            <a:tbl>
-              <a:tblPr bandRow="1" firstRow="1">
-                <a:noFill/>
-                <a:tableStyleId>{A1D2862B-52F9-4485-B6A9-9AC04C1CC2F1}</a:tableStyleId>
-              </a:tblPr>
-              <a:tblGrid>
-                <a:gridCol w="2638875"/>
-                <a:gridCol w="1458825"/>
-                <a:gridCol w="1372950"/>
-                <a:gridCol w="1952325"/>
-                <a:gridCol w="1877175"/>
-                <a:gridCol w="1748875"/>
-              </a:tblGrid>
-              <a:tr h="394325">
-                <a:tc>
-                  <a:txBody>
-                    <a:bodyPr/>
-                    <a:lstStyle/>
-                    <a:p>
-                      <a:pPr indent="0" lvl="0" marL="0" marR="0" rtl="0" algn="l">
-                        <a:spcBef>
-                          <a:spcPts val="0"/>
-                        </a:spcBef>
-                        <a:spcAft>
-                          <a:spcPts val="0"/>
-                        </a:spcAft>
-                        <a:buNone/>
-                      </a:pPr>
-                      <a:r>
-                        <a:rPr b="1" i="0" lang="en-US" sz="975" u="none" cap="none" strike="noStrike">
-                          <a:solidFill>
-                            <a:srgbClr val="FDFBF7"/>
-                          </a:solidFill>
-                          <a:latin typeface="Cinzel"/>
-                          <a:ea typeface="Cinzel"/>
-                          <a:cs typeface="Cinzel"/>
-                          <a:sym typeface="Cinzel"/>
-                        </a:rPr>
-                        <a:t>Modèle Conçu sous Blender</a:t>
-                      </a:r>
-                      <a:endParaRPr/>
-                    </a:p>
-                  </a:txBody>
-                  <a:tcPr marT="25400" marB="25400" marR="63500" marL="63500" anchor="ctr">
-                    <a:lnL cap="flat" cmpd="sng" w="9525">
-                      <a:solidFill>
-                        <a:srgbClr val="000000">
-                          <a:alpha val="0"/>
-                        </a:srgbClr>
-                      </a:solidFill>
-                      <a:prstDash val="solid"/>
-                      <a:round/>
-                      <a:headEnd len="sm" w="sm" type="none"/>
-                      <a:tailEnd len="sm" w="sm" type="none"/>
-                    </a:lnL>
-                    <a:lnR cap="flat" cmpd="sng" w="9525">
-                      <a:solidFill>
-                        <a:srgbClr val="000000">
-                          <a:alpha val="0"/>
-                        </a:srgbClr>
-                      </a:solidFill>
-                      <a:prstDash val="solid"/>
-                      <a:round/>
-                      <a:headEnd len="sm" w="sm" type="none"/>
-                      <a:tailEnd len="sm" w="sm" type="none"/>
-                    </a:lnR>
-                    <a:lnT cap="flat" cmpd="sng" w="9525">
-                      <a:solidFill>
-                        <a:srgbClr val="000000">
-                          <a:alpha val="0"/>
-                        </a:srgbClr>
-                      </a:solidFill>
-                      <a:prstDash val="solid"/>
-                      <a:round/>
-                      <a:headEnd len="sm" w="sm" type="none"/>
-                      <a:tailEnd len="sm" w="sm" type="none"/>
-                    </a:lnT>
-                    <a:lnB cap="flat" cmpd="sng" w="9525">
-                      <a:solidFill>
-                        <a:srgbClr val="000000">
-                          <a:alpha val="0"/>
-                        </a:srgbClr>
-                      </a:solidFill>
-                      <a:prstDash val="solid"/>
-                      <a:round/>
-                      <a:headEnd len="sm" w="sm" type="none"/>
-                      <a:tailEnd len="sm" w="sm" type="none"/>
-                    </a:lnB>
-                    <a:solidFill>
-                      <a:srgbClr val="1E2E1F"/>
-                    </a:solidFill>
-                  </a:tcPr>
-                </a:tc>
-                <a:tc>
-                  <a:txBody>
-                    <a:bodyPr/>
-                    <a:lstStyle/>
-                    <a:p>
-                      <a:pPr indent="0" lvl="0" marL="0" marR="0" rtl="0" algn="l">
-                        <a:spcBef>
-                          <a:spcPts val="0"/>
-                        </a:spcBef>
-                        <a:spcAft>
-                          <a:spcPts val="0"/>
-                        </a:spcAft>
-                        <a:buNone/>
-                      </a:pPr>
-                      <a:r>
-                        <a:rPr b="1" i="0" lang="en-US" sz="975" u="none" cap="none" strike="noStrike">
-                          <a:solidFill>
-                            <a:srgbClr val="FDFBF7"/>
-                          </a:solidFill>
-                          <a:latin typeface="Cinzel"/>
-                          <a:ea typeface="Cinzel"/>
-                          <a:cs typeface="Cinzel"/>
-                          <a:sym typeface="Cinzel"/>
-                        </a:rPr>
-                        <a:t>Format Réel</a:t>
-                      </a:r>
-                      <a:endParaRPr/>
-                    </a:p>
-                  </a:txBody>
-                  <a:tcPr marT="25400" marB="25400" marR="63500" marL="63500" anchor="ctr">
-                    <a:lnL cap="flat" cmpd="sng" w="9525">
-                      <a:solidFill>
-                        <a:srgbClr val="000000">
-                          <a:alpha val="0"/>
-                        </a:srgbClr>
-                      </a:solidFill>
-                      <a:prstDash val="solid"/>
-                      <a:round/>
-                      <a:headEnd len="sm" w="sm" type="none"/>
-                      <a:tailEnd len="sm" w="sm" type="none"/>
-                    </a:lnL>
-                    <a:lnR cap="flat" cmpd="sng" w="9525">
-                      <a:solidFill>
-                        <a:srgbClr val="000000">
-                          <a:alpha val="0"/>
-                        </a:srgbClr>
-                      </a:solidFill>
-                      <a:prstDash val="solid"/>
-                      <a:round/>
-                      <a:headEnd len="sm" w="sm" type="none"/>
-                      <a:tailEnd len="sm" w="sm" type="none"/>
-                    </a:lnR>
-                    <a:lnT cap="flat" cmpd="sng" w="9525">
-                      <a:solidFill>
-                        <a:srgbClr val="000000">
-                          <a:alpha val="0"/>
-                        </a:srgbClr>
-                      </a:solidFill>
-                      <a:prstDash val="solid"/>
-                      <a:round/>
-                      <a:headEnd len="sm" w="sm" type="none"/>
-                      <a:tailEnd len="sm" w="sm" type="none"/>
-                    </a:lnT>
-                    <a:lnB cap="flat" cmpd="sng" w="9525">
-                      <a:solidFill>
-                        <a:srgbClr val="000000">
-                          <a:alpha val="0"/>
-                        </a:srgbClr>
-                      </a:solidFill>
-                      <a:prstDash val="solid"/>
-                      <a:round/>
-                      <a:headEnd len="sm" w="sm" type="none"/>
-                      <a:tailEnd len="sm" w="sm" type="none"/>
-                    </a:lnB>
-                    <a:solidFill>
-                      <a:srgbClr val="1E2E1F"/>
-                    </a:solidFill>
-                  </a:tcPr>
-                </a:tc>
-                <a:tc>
-                  <a:txBody>
-                    <a:bodyPr/>
-                    <a:lstStyle/>
-                    <a:p>
-                      <a:pPr indent="0" lvl="0" marL="0" marR="0" rtl="0" algn="l">
-                        <a:spcBef>
-                          <a:spcPts val="0"/>
-                        </a:spcBef>
-                        <a:spcAft>
-                          <a:spcPts val="0"/>
-                        </a:spcAft>
-                        <a:buNone/>
-                      </a:pPr>
-                      <a:r>
-                        <a:rPr b="1" i="0" lang="en-US" sz="975" u="none" cap="none" strike="noStrike">
-                          <a:solidFill>
-                            <a:srgbClr val="FDFBF7"/>
-                          </a:solidFill>
-                          <a:latin typeface="Cinzel"/>
-                          <a:ea typeface="Cinzel"/>
-                          <a:cs typeface="Cinzel"/>
-                          <a:sym typeface="Cinzel"/>
-                        </a:rPr>
-                        <a:t>Poids Initial</a:t>
-                      </a:r>
-                      <a:endParaRPr/>
-                    </a:p>
-                  </a:txBody>
-                  <a:tcPr marT="25400" marB="25400" marR="63500" marL="63500" anchor="ctr">
-                    <a:lnL cap="flat" cmpd="sng" w="9525">
-                      <a:solidFill>
-                        <a:srgbClr val="000000">
-                          <a:alpha val="0"/>
-                        </a:srgbClr>
-                      </a:solidFill>
-                      <a:prstDash val="solid"/>
-                      <a:round/>
-                      <a:headEnd len="sm" w="sm" type="none"/>
-                      <a:tailEnd len="sm" w="sm" type="none"/>
-                    </a:lnL>
-                    <a:lnR cap="flat" cmpd="sng" w="9525">
-                      <a:solidFill>
-                        <a:srgbClr val="000000">
-                          <a:alpha val="0"/>
-                        </a:srgbClr>
-                      </a:solidFill>
-                      <a:prstDash val="solid"/>
-                      <a:round/>
-                      <a:headEnd len="sm" w="sm" type="none"/>
-                      <a:tailEnd len="sm" w="sm" type="none"/>
-                    </a:lnR>
-                    <a:lnT cap="flat" cmpd="sng" w="9525">
-                      <a:solidFill>
-                        <a:srgbClr val="000000">
-                          <a:alpha val="0"/>
-                        </a:srgbClr>
-                      </a:solidFill>
-                      <a:prstDash val="solid"/>
-                      <a:round/>
-                      <a:headEnd len="sm" w="sm" type="none"/>
-                      <a:tailEnd len="sm" w="sm" type="none"/>
-                    </a:lnT>
-                    <a:lnB cap="flat" cmpd="sng" w="9525">
-                      <a:solidFill>
-                        <a:srgbClr val="000000">
-                          <a:alpha val="0"/>
-                        </a:srgbClr>
-                      </a:solidFill>
-                      <a:prstDash val="solid"/>
-                      <a:round/>
-                      <a:headEnd len="sm" w="sm" type="none"/>
-                      <a:tailEnd len="sm" w="sm" type="none"/>
-                    </a:lnB>
-                    <a:solidFill>
-                      <a:srgbClr val="1E2E1F"/>
-                    </a:solidFill>
-                  </a:tcPr>
-                </a:tc>
-                <a:tc>
-                  <a:txBody>
-                    <a:bodyPr/>
-                    <a:lstStyle/>
-                    <a:p>
-                      <a:pPr indent="0" lvl="0" marL="0" marR="0" rtl="0" algn="l">
-                        <a:spcBef>
-                          <a:spcPts val="0"/>
-                        </a:spcBef>
-                        <a:spcAft>
-                          <a:spcPts val="0"/>
-                        </a:spcAft>
-                        <a:buNone/>
-                      </a:pPr>
-                      <a:r>
-                        <a:rPr b="1" i="0" lang="en-US" sz="975" u="none" cap="none" strike="noStrike">
-                          <a:solidFill>
-                            <a:srgbClr val="FDFBF7"/>
-                          </a:solidFill>
-                          <a:latin typeface="Cinzel"/>
-                          <a:ea typeface="Cinzel"/>
-                          <a:cs typeface="Cinzel"/>
-                          <a:sym typeface="Cinzel"/>
-                        </a:rPr>
-                        <a:t>Poids WebP Optimisé</a:t>
-                      </a:r>
-                      <a:endParaRPr/>
-                    </a:p>
-                  </a:txBody>
-                  <a:tcPr marT="25400" marB="25400" marR="63500" marL="63500" anchor="ctr">
-                    <a:lnL cap="flat" cmpd="sng" w="9525">
-                      <a:solidFill>
-                        <a:srgbClr val="000000">
-                          <a:alpha val="0"/>
-                        </a:srgbClr>
-                      </a:solidFill>
-                      <a:prstDash val="solid"/>
-                      <a:round/>
-                      <a:headEnd len="sm" w="sm" type="none"/>
-                      <a:tailEnd len="sm" w="sm" type="none"/>
-                    </a:lnL>
-                    <a:lnR cap="flat" cmpd="sng" w="9525">
-                      <a:solidFill>
-                        <a:srgbClr val="000000">
-                          <a:alpha val="0"/>
-                        </a:srgbClr>
-                      </a:solidFill>
-                      <a:prstDash val="solid"/>
-                      <a:round/>
-                      <a:headEnd len="sm" w="sm" type="none"/>
-                      <a:tailEnd len="sm" w="sm" type="none"/>
-                    </a:lnR>
-                    <a:lnT cap="flat" cmpd="sng" w="9525">
-                      <a:solidFill>
-                        <a:srgbClr val="000000">
-                          <a:alpha val="0"/>
-                        </a:srgbClr>
-                      </a:solidFill>
-                      <a:prstDash val="solid"/>
-                      <a:round/>
-                      <a:headEnd len="sm" w="sm" type="none"/>
-                      <a:tailEnd len="sm" w="sm" type="none"/>
-                    </a:lnT>
-                    <a:lnB cap="flat" cmpd="sng" w="9525">
-                      <a:solidFill>
-                        <a:srgbClr val="000000">
-                          <a:alpha val="0"/>
-                        </a:srgbClr>
-                      </a:solidFill>
-                      <a:prstDash val="solid"/>
-                      <a:round/>
-                      <a:headEnd len="sm" w="sm" type="none"/>
-                      <a:tailEnd len="sm" w="sm" type="none"/>
-                    </a:lnB>
-                    <a:solidFill>
-                      <a:srgbClr val="1E2E1F"/>
-                    </a:solidFill>
-                  </a:tcPr>
-                </a:tc>
-                <a:tc>
-                  <a:txBody>
-                    <a:bodyPr/>
-                    <a:lstStyle/>
-                    <a:p>
-                      <a:pPr indent="0" lvl="0" marL="0" marR="0" rtl="0" algn="l">
-                        <a:spcBef>
-                          <a:spcPts val="0"/>
-                        </a:spcBef>
-                        <a:spcAft>
-                          <a:spcPts val="0"/>
-                        </a:spcAft>
-                        <a:buNone/>
-                      </a:pPr>
-                      <a:r>
-                        <a:rPr b="1" i="0" lang="en-US" sz="975" u="none" cap="none" strike="noStrike">
-                          <a:solidFill>
-                            <a:srgbClr val="FDFBF7"/>
-                          </a:solidFill>
-                          <a:latin typeface="Cinzel"/>
-                          <a:ea typeface="Cinzel"/>
-                          <a:cs typeface="Cinzel"/>
-                          <a:sym typeface="Cinzel"/>
-                        </a:rPr>
-                        <a:t>Réduction Globale</a:t>
-                      </a:r>
-                      <a:endParaRPr/>
-                    </a:p>
-                  </a:txBody>
-                  <a:tcPr marT="25400" marB="25400" marR="63500" marL="63500" anchor="ctr">
-                    <a:lnL cap="flat" cmpd="sng" w="9525">
-                      <a:solidFill>
-                        <a:srgbClr val="000000">
-                          <a:alpha val="0"/>
-                        </a:srgbClr>
-                      </a:solidFill>
-                      <a:prstDash val="solid"/>
-                      <a:round/>
-                      <a:headEnd len="sm" w="sm" type="none"/>
-                      <a:tailEnd len="sm" w="sm" type="none"/>
-                    </a:lnL>
-                    <a:lnR cap="flat" cmpd="sng" w="9525">
-                      <a:solidFill>
-                        <a:srgbClr val="000000">
-                          <a:alpha val="0"/>
-                        </a:srgbClr>
-                      </a:solidFill>
-                      <a:prstDash val="solid"/>
-                      <a:round/>
-                      <a:headEnd len="sm" w="sm" type="none"/>
-                      <a:tailEnd len="sm" w="sm" type="none"/>
-                    </a:lnR>
-                    <a:lnT cap="flat" cmpd="sng" w="9525">
-                      <a:solidFill>
-                        <a:srgbClr val="000000">
-                          <a:alpha val="0"/>
-                        </a:srgbClr>
-                      </a:solidFill>
-                      <a:prstDash val="solid"/>
-                      <a:round/>
-                      <a:headEnd len="sm" w="sm" type="none"/>
-                      <a:tailEnd len="sm" w="sm" type="none"/>
-                    </a:lnT>
-                    <a:lnB cap="flat" cmpd="sng" w="9525">
-                      <a:solidFill>
-                        <a:srgbClr val="000000">
-                          <a:alpha val="0"/>
-                        </a:srgbClr>
-                      </a:solidFill>
-                      <a:prstDash val="solid"/>
-                      <a:round/>
-                      <a:headEnd len="sm" w="sm" type="none"/>
-                      <a:tailEnd len="sm" w="sm" type="none"/>
-                    </a:lnB>
-                    <a:solidFill>
-                      <a:srgbClr val="1E2E1F"/>
-                    </a:solidFill>
-                  </a:tcPr>
-                </a:tc>
-                <a:tc>
-                  <a:txBody>
-                    <a:bodyPr/>
-                    <a:lstStyle/>
-                    <a:p>
-                      <a:pPr indent="0" lvl="0" marL="0" marR="0" rtl="0" algn="l">
-                        <a:spcBef>
-                          <a:spcPts val="0"/>
-                        </a:spcBef>
-                        <a:spcAft>
-                          <a:spcPts val="0"/>
-                        </a:spcAft>
-                        <a:buNone/>
-                      </a:pPr>
-                      <a:r>
-                        <a:rPr b="1" i="0" lang="en-US" sz="975" u="none" cap="none" strike="noStrike">
-                          <a:solidFill>
-                            <a:srgbClr val="FDFBF7"/>
-                          </a:solidFill>
-                          <a:latin typeface="Cinzel"/>
-                          <a:ea typeface="Cinzel"/>
-                          <a:cs typeface="Cinzel"/>
-                          <a:sym typeface="Cinzel"/>
-                        </a:rPr>
-                        <a:t>Statut Validation</a:t>
-                      </a:r>
-                      <a:endParaRPr/>
-                    </a:p>
-                  </a:txBody>
-                  <a:tcPr marT="25400" marB="25400" marR="63500" marL="63500" anchor="ctr">
-                    <a:lnL cap="flat" cmpd="sng" w="9525">
-                      <a:solidFill>
-                        <a:srgbClr val="000000">
-                          <a:alpha val="0"/>
-                        </a:srgbClr>
-                      </a:solidFill>
-                      <a:prstDash val="solid"/>
-                      <a:round/>
-                      <a:headEnd len="sm" w="sm" type="none"/>
-                      <a:tailEnd len="sm" w="sm" type="none"/>
-                    </a:lnL>
-                    <a:lnR cap="flat" cmpd="sng" w="9525">
-                      <a:solidFill>
-                        <a:srgbClr val="000000">
-                          <a:alpha val="0"/>
-                        </a:srgbClr>
-                      </a:solidFill>
-                      <a:prstDash val="solid"/>
-                      <a:round/>
-                      <a:headEnd len="sm" w="sm" type="none"/>
-                      <a:tailEnd len="sm" w="sm" type="none"/>
-                    </a:lnR>
-                    <a:lnT cap="flat" cmpd="sng" w="9525">
-                      <a:solidFill>
-                        <a:srgbClr val="000000">
-                          <a:alpha val="0"/>
-                        </a:srgbClr>
-                      </a:solidFill>
-                      <a:prstDash val="solid"/>
-                      <a:round/>
-                      <a:headEnd len="sm" w="sm" type="none"/>
-                      <a:tailEnd len="sm" w="sm" type="none"/>
-                    </a:lnT>
-                    <a:lnB cap="flat" cmpd="sng" w="9525">
-                      <a:solidFill>
-                        <a:srgbClr val="000000">
-                          <a:alpha val="0"/>
-                        </a:srgbClr>
-                      </a:solidFill>
-                      <a:prstDash val="solid"/>
-                      <a:round/>
-                      <a:headEnd len="sm" w="sm" type="none"/>
-                      <a:tailEnd len="sm" w="sm" type="none"/>
-                    </a:lnB>
-                    <a:solidFill>
-                      <a:srgbClr val="1E2E1F"/>
-                    </a:solidFill>
-                  </a:tcPr>
-                </a:tc>
-              </a:tr>
-              <a:tr h="394325">
-                <a:tc>
-                  <a:txBody>
-                    <a:bodyPr/>
-                    <a:lstStyle/>
-                    <a:p>
-                      <a:pPr indent="0" lvl="0" marL="0" marR="0" rtl="0" algn="l">
-                        <a:spcBef>
-                          <a:spcPts val="0"/>
-                        </a:spcBef>
-                        <a:spcAft>
-                          <a:spcPts val="0"/>
-                        </a:spcAft>
-                        <a:buNone/>
-                      </a:pPr>
-                      <a:r>
-                        <a:rPr b="0" i="0" lang="en-US" sz="975" u="none" cap="none" strike="noStrike">
-                          <a:solidFill>
-                            <a:srgbClr val="000000"/>
-                          </a:solidFill>
-                          <a:latin typeface="Montserrat"/>
-                          <a:ea typeface="Montserrat"/>
-                          <a:cs typeface="Montserrat"/>
-                          <a:sym typeface="Montserrat"/>
-                        </a:rPr>
-                        <a:t>Bouteille Cylindrique 500 ml</a:t>
-                      </a:r>
-                      <a:endParaRPr/>
-                    </a:p>
-                  </a:txBody>
-                  <a:tcPr marT="25400" marB="25400" marR="63500" marL="63500" anchor="ctr">
-                    <a:lnL cap="flat" cmpd="sng" w="9525">
-                      <a:solidFill>
-                        <a:srgbClr val="000000">
-                          <a:alpha val="0"/>
-                        </a:srgbClr>
-                      </a:solidFill>
-                      <a:prstDash val="solid"/>
-                      <a:round/>
-                      <a:headEnd len="sm" w="sm" type="none"/>
-                      <a:tailEnd len="sm" w="sm" type="none"/>
-                    </a:lnL>
-                    <a:lnR cap="flat" cmpd="sng" w="9525">
-                      <a:solidFill>
-                        <a:srgbClr val="000000">
-                          <a:alpha val="0"/>
-                        </a:srgbClr>
-                      </a:solidFill>
-                      <a:prstDash val="solid"/>
-                      <a:round/>
-                      <a:headEnd len="sm" w="sm" type="none"/>
-                      <a:tailEnd len="sm" w="sm" type="none"/>
-                    </a:lnR>
-                    <a:lnT cap="flat" cmpd="sng" w="9525">
-                      <a:solidFill>
-                        <a:srgbClr val="000000">
-                          <a:alpha val="0"/>
-                        </a:srgbClr>
-                      </a:solidFill>
-                      <a:prstDash val="solid"/>
-                      <a:round/>
-                      <a:headEnd len="sm" w="sm" type="none"/>
-                      <a:tailEnd len="sm" w="sm" type="none"/>
-                    </a:lnT>
-                    <a:lnB cap="flat" cmpd="sng" w="9525">
-                      <a:solidFill>
-                        <a:srgbClr val="000000">
-                          <a:alpha val="0"/>
-                        </a:srgbClr>
-                      </a:solidFill>
-                      <a:prstDash val="solid"/>
-                      <a:round/>
-                      <a:headEnd len="sm" w="sm" type="none"/>
-                      <a:tailEnd len="sm" w="sm" type="none"/>
-                    </a:lnB>
-                  </a:tcPr>
-                </a:tc>
-                <a:tc>
-                  <a:txBody>
-                    <a:bodyPr/>
-                    <a:lstStyle/>
-                    <a:p>
-                      <a:pPr indent="0" lvl="0" marL="0" marR="0" rtl="0" algn="l">
-                        <a:spcBef>
-                          <a:spcPts val="0"/>
-                        </a:spcBef>
-                        <a:spcAft>
-                          <a:spcPts val="0"/>
-                        </a:spcAft>
-                        <a:buNone/>
-                      </a:pPr>
-                      <a:r>
-                        <a:rPr b="0" i="0" lang="en-US" sz="975" u="none" cap="none" strike="noStrike">
-                          <a:solidFill>
-                            <a:srgbClr val="000000"/>
-                          </a:solidFill>
-                          <a:latin typeface="Montserrat"/>
-                          <a:ea typeface="Montserrat"/>
-                          <a:cs typeface="Montserrat"/>
-                          <a:sym typeface="Montserrat"/>
-                        </a:rPr>
-                        <a:t>Verre Premium</a:t>
-                      </a:r>
-                      <a:endParaRPr/>
-                    </a:p>
-                  </a:txBody>
-                  <a:tcPr marT="25400" marB="25400" marR="63500" marL="63500" anchor="ctr">
-                    <a:lnL cap="flat" cmpd="sng" w="9525">
-                      <a:solidFill>
-                        <a:srgbClr val="000000">
-                          <a:alpha val="0"/>
-                        </a:srgbClr>
-                      </a:solidFill>
-                      <a:prstDash val="solid"/>
-                      <a:round/>
-                      <a:headEnd len="sm" w="sm" type="none"/>
-                      <a:tailEnd len="sm" w="sm" type="none"/>
-                    </a:lnL>
-                    <a:lnR cap="flat" cmpd="sng" w="9525">
-                      <a:solidFill>
-                        <a:srgbClr val="000000">
-                          <a:alpha val="0"/>
-                        </a:srgbClr>
-                      </a:solidFill>
-                      <a:prstDash val="solid"/>
-                      <a:round/>
-                      <a:headEnd len="sm" w="sm" type="none"/>
-                      <a:tailEnd len="sm" w="sm" type="none"/>
-                    </a:lnR>
-                    <a:lnT cap="flat" cmpd="sng" w="9525">
-                      <a:solidFill>
-                        <a:srgbClr val="000000">
-                          <a:alpha val="0"/>
-                        </a:srgbClr>
-                      </a:solidFill>
-                      <a:prstDash val="solid"/>
-                      <a:round/>
-                      <a:headEnd len="sm" w="sm" type="none"/>
-                      <a:tailEnd len="sm" w="sm" type="none"/>
-                    </a:lnT>
-                    <a:lnB cap="flat" cmpd="sng" w="9525">
-                      <a:solidFill>
-                        <a:srgbClr val="000000">
-                          <a:alpha val="0"/>
-                        </a:srgbClr>
-                      </a:solidFill>
-                      <a:prstDash val="solid"/>
-                      <a:round/>
-                      <a:headEnd len="sm" w="sm" type="none"/>
-                      <a:tailEnd len="sm" w="sm" type="none"/>
-                    </a:lnB>
-                  </a:tcPr>
-                </a:tc>
-                <a:tc>
-                  <a:txBody>
-                    <a:bodyPr/>
-                    <a:lstStyle/>
-                    <a:p>
-                      <a:pPr indent="0" lvl="0" marL="0" marR="0" rtl="0" algn="l">
-                        <a:spcBef>
-                          <a:spcPts val="0"/>
-                        </a:spcBef>
-                        <a:spcAft>
-                          <a:spcPts val="0"/>
-                        </a:spcAft>
-                        <a:buNone/>
-                      </a:pPr>
-                      <a:r>
-                        <a:rPr b="0" i="0" lang="en-US" sz="975" u="none" cap="none" strike="noStrike">
-                          <a:solidFill>
-                            <a:srgbClr val="000000"/>
-                          </a:solidFill>
-                          <a:latin typeface="Montserrat"/>
-                          <a:ea typeface="Montserrat"/>
-                          <a:cs typeface="Montserrat"/>
-                          <a:sym typeface="Montserrat"/>
-                        </a:rPr>
-                        <a:t>12,4 Mo</a:t>
-                      </a:r>
-                      <a:endParaRPr/>
-                    </a:p>
-                  </a:txBody>
-                  <a:tcPr marT="25400" marB="25400" marR="63500" marL="63500" anchor="ctr">
-                    <a:lnL cap="flat" cmpd="sng" w="9525">
-                      <a:solidFill>
-                        <a:srgbClr val="000000">
-                          <a:alpha val="0"/>
-                        </a:srgbClr>
-                      </a:solidFill>
-                      <a:prstDash val="solid"/>
-                      <a:round/>
-                      <a:headEnd len="sm" w="sm" type="none"/>
-                      <a:tailEnd len="sm" w="sm" type="none"/>
-                    </a:lnL>
-                    <a:lnR cap="flat" cmpd="sng" w="9525">
-                      <a:solidFill>
-                        <a:srgbClr val="000000">
-                          <a:alpha val="0"/>
-                        </a:srgbClr>
-                      </a:solidFill>
-                      <a:prstDash val="solid"/>
-                      <a:round/>
-                      <a:headEnd len="sm" w="sm" type="none"/>
-                      <a:tailEnd len="sm" w="sm" type="none"/>
-                    </a:lnR>
-                    <a:lnT cap="flat" cmpd="sng" w="9525">
-                      <a:solidFill>
-                        <a:srgbClr val="000000">
-                          <a:alpha val="0"/>
-                        </a:srgbClr>
-                      </a:solidFill>
-                      <a:prstDash val="solid"/>
-                      <a:round/>
-                      <a:headEnd len="sm" w="sm" type="none"/>
-                      <a:tailEnd len="sm" w="sm" type="none"/>
-                    </a:lnT>
-                    <a:lnB cap="flat" cmpd="sng" w="9525">
-                      <a:solidFill>
-                        <a:srgbClr val="000000">
-                          <a:alpha val="0"/>
-                        </a:srgbClr>
-                      </a:solidFill>
-                      <a:prstDash val="solid"/>
-                      <a:round/>
-                      <a:headEnd len="sm" w="sm" type="none"/>
-                      <a:tailEnd len="sm" w="sm" type="none"/>
-                    </a:lnB>
-                  </a:tcPr>
-                </a:tc>
-                <a:tc>
-                  <a:txBody>
-                    <a:bodyPr/>
-                    <a:lstStyle/>
-                    <a:p>
-                      <a:pPr indent="0" lvl="0" marL="0" marR="0" rtl="0" algn="l">
-                        <a:spcBef>
-                          <a:spcPts val="0"/>
-                        </a:spcBef>
-                        <a:spcAft>
-                          <a:spcPts val="0"/>
-                        </a:spcAft>
-                        <a:buNone/>
-                      </a:pPr>
-                      <a:r>
-                        <a:rPr b="0" i="0" lang="en-US" sz="975" u="none" cap="none" strike="noStrike">
-                          <a:solidFill>
-                            <a:srgbClr val="000000"/>
-                          </a:solidFill>
-                          <a:latin typeface="Montserrat"/>
-                          <a:ea typeface="Montserrat"/>
-                          <a:cs typeface="Montserrat"/>
-                          <a:sym typeface="Montserrat"/>
-                        </a:rPr>
-                        <a:t>3,85 Mo</a:t>
-                      </a:r>
-                      <a:endParaRPr/>
-                    </a:p>
-                  </a:txBody>
-                  <a:tcPr marT="25400" marB="25400" marR="63500" marL="63500" anchor="ctr">
-                    <a:lnL cap="flat" cmpd="sng" w="9525">
-                      <a:solidFill>
-                        <a:srgbClr val="000000">
-                          <a:alpha val="0"/>
-                        </a:srgbClr>
-                      </a:solidFill>
-                      <a:prstDash val="solid"/>
-                      <a:round/>
-                      <a:headEnd len="sm" w="sm" type="none"/>
-                      <a:tailEnd len="sm" w="sm" type="none"/>
-                    </a:lnL>
-                    <a:lnR cap="flat" cmpd="sng" w="9525">
-                      <a:solidFill>
-                        <a:srgbClr val="000000">
-                          <a:alpha val="0"/>
-                        </a:srgbClr>
-                      </a:solidFill>
-                      <a:prstDash val="solid"/>
-                      <a:round/>
-                      <a:headEnd len="sm" w="sm" type="none"/>
-                      <a:tailEnd len="sm" w="sm" type="none"/>
-                    </a:lnR>
-                    <a:lnT cap="flat" cmpd="sng" w="9525">
-                      <a:solidFill>
-                        <a:srgbClr val="000000">
-                          <a:alpha val="0"/>
-                        </a:srgbClr>
-                      </a:solidFill>
-                      <a:prstDash val="solid"/>
-                      <a:round/>
-                      <a:headEnd len="sm" w="sm" type="none"/>
-                      <a:tailEnd len="sm" w="sm" type="none"/>
-                    </a:lnT>
-                    <a:lnB cap="flat" cmpd="sng" w="9525">
-                      <a:solidFill>
-                        <a:srgbClr val="000000">
-                          <a:alpha val="0"/>
-                        </a:srgbClr>
-                      </a:solidFill>
-                      <a:prstDash val="solid"/>
-                      <a:round/>
-                      <a:headEnd len="sm" w="sm" type="none"/>
-                      <a:tailEnd len="sm" w="sm" type="none"/>
-                    </a:lnB>
-                  </a:tcPr>
-                </a:tc>
-                <a:tc>
-                  <a:txBody>
-                    <a:bodyPr/>
-                    <a:lstStyle/>
-                    <a:p>
-                      <a:pPr indent="0" lvl="0" marL="0" marR="0" rtl="0" algn="l">
-                        <a:spcBef>
-                          <a:spcPts val="0"/>
-                        </a:spcBef>
-                        <a:spcAft>
-                          <a:spcPts val="0"/>
-                        </a:spcAft>
-                        <a:buNone/>
-                      </a:pPr>
-                      <a:r>
-                        <a:rPr b="1" i="0" lang="en-US" sz="975" u="none" cap="none" strike="noStrike">
-                          <a:solidFill>
-                            <a:srgbClr val="000000"/>
-                          </a:solidFill>
-                          <a:latin typeface="Montserrat"/>
-                          <a:ea typeface="Montserrat"/>
-                          <a:cs typeface="Montserrat"/>
-                          <a:sym typeface="Montserrat"/>
-                        </a:rPr>
-                        <a:t>-69%</a:t>
-                      </a:r>
-                      <a:endParaRPr/>
-                    </a:p>
-                  </a:txBody>
-                  <a:tcPr marT="25400" marB="25400" marR="63500" marL="63500" anchor="ctr">
-                    <a:lnL cap="flat" cmpd="sng" w="9525">
-                      <a:solidFill>
-                        <a:srgbClr val="000000">
-                          <a:alpha val="0"/>
-                        </a:srgbClr>
-                      </a:solidFill>
-                      <a:prstDash val="solid"/>
-                      <a:round/>
-                      <a:headEnd len="sm" w="sm" type="none"/>
-                      <a:tailEnd len="sm" w="sm" type="none"/>
-                    </a:lnL>
-                    <a:lnR cap="flat" cmpd="sng" w="9525">
-                      <a:solidFill>
-                        <a:srgbClr val="000000">
-                          <a:alpha val="0"/>
-                        </a:srgbClr>
-                      </a:solidFill>
-                      <a:prstDash val="solid"/>
-                      <a:round/>
-                      <a:headEnd len="sm" w="sm" type="none"/>
-                      <a:tailEnd len="sm" w="sm" type="none"/>
-                    </a:lnR>
-                    <a:lnT cap="flat" cmpd="sng" w="9525">
-                      <a:solidFill>
-                        <a:srgbClr val="000000">
-                          <a:alpha val="0"/>
-                        </a:srgbClr>
-                      </a:solidFill>
-                      <a:prstDash val="solid"/>
-                      <a:round/>
-                      <a:headEnd len="sm" w="sm" type="none"/>
-                      <a:tailEnd len="sm" w="sm" type="none"/>
-                    </a:lnT>
-                    <a:lnB cap="flat" cmpd="sng" w="9525">
-                      <a:solidFill>
-                        <a:srgbClr val="000000">
-                          <a:alpha val="0"/>
-                        </a:srgbClr>
-                      </a:solidFill>
-                      <a:prstDash val="solid"/>
-                      <a:round/>
-                      <a:headEnd len="sm" w="sm" type="none"/>
-                      <a:tailEnd len="sm" w="sm" type="none"/>
-                    </a:lnB>
-                  </a:tcPr>
-                </a:tc>
-                <a:tc>
-                  <a:txBody>
-                    <a:bodyPr/>
-                    <a:lstStyle/>
-                    <a:p>
-                      <a:pPr indent="0" lvl="0" marL="0" marR="0" rtl="0" algn="l">
-                        <a:spcBef>
-                          <a:spcPts val="0"/>
-                        </a:spcBef>
-                        <a:spcAft>
-                          <a:spcPts val="0"/>
-                        </a:spcAft>
-                        <a:buNone/>
-                      </a:pPr>
-                      <a:r>
-                        <a:rPr b="1" i="0" lang="en-US" sz="975" u="none" cap="none" strike="noStrike">
-                          <a:solidFill>
-                            <a:srgbClr val="3B533E"/>
-                          </a:solidFill>
-                          <a:latin typeface="Montserrat"/>
-                          <a:ea typeface="Montserrat"/>
-                          <a:cs typeface="Montserrat"/>
-                          <a:sym typeface="Montserrat"/>
-                        </a:rPr>
-                        <a:t> Validé</a:t>
-                      </a:r>
-                      <a:endParaRPr/>
-                    </a:p>
-                  </a:txBody>
-                  <a:tcPr marT="25400" marB="25400" marR="63500" marL="238125" anchor="ctr">
-                    <a:lnL cap="flat" cmpd="sng" w="9525">
-                      <a:solidFill>
-                        <a:srgbClr val="000000">
-                          <a:alpha val="0"/>
-                        </a:srgbClr>
-                      </a:solidFill>
-                      <a:prstDash val="solid"/>
-                      <a:round/>
-                      <a:headEnd len="sm" w="sm" type="none"/>
-                      <a:tailEnd len="sm" w="sm" type="none"/>
-                    </a:lnL>
-                    <a:lnR cap="flat" cmpd="sng" w="9525">
-                      <a:solidFill>
-                        <a:srgbClr val="000000">
-                          <a:alpha val="0"/>
-                        </a:srgbClr>
-                      </a:solidFill>
-                      <a:prstDash val="solid"/>
-                      <a:round/>
-                      <a:headEnd len="sm" w="sm" type="none"/>
-                      <a:tailEnd len="sm" w="sm" type="none"/>
-                    </a:lnR>
-                    <a:lnT cap="flat" cmpd="sng" w="9525">
-                      <a:solidFill>
-                        <a:srgbClr val="000000">
-                          <a:alpha val="0"/>
-                        </a:srgbClr>
-                      </a:solidFill>
-                      <a:prstDash val="solid"/>
-                      <a:round/>
-                      <a:headEnd len="sm" w="sm" type="none"/>
-                      <a:tailEnd len="sm" w="sm" type="none"/>
-                    </a:lnT>
-                    <a:lnB cap="flat" cmpd="sng" w="9525">
-                      <a:solidFill>
-                        <a:srgbClr val="000000">
-                          <a:alpha val="0"/>
-                        </a:srgbClr>
-                      </a:solidFill>
-                      <a:prstDash val="solid"/>
-                      <a:round/>
-                      <a:headEnd len="sm" w="sm" type="none"/>
-                      <a:tailEnd len="sm" w="sm" type="none"/>
-                    </a:lnB>
-                  </a:tcPr>
-                </a:tc>
-              </a:tr>
-              <a:tr h="394325">
-                <a:tc>
-                  <a:txBody>
-                    <a:bodyPr/>
-                    <a:lstStyle/>
-                    <a:p>
-                      <a:pPr indent="0" lvl="0" marL="0" marR="0" rtl="0" algn="l">
-                        <a:spcBef>
-                          <a:spcPts val="0"/>
-                        </a:spcBef>
-                        <a:spcAft>
-                          <a:spcPts val="0"/>
-                        </a:spcAft>
-                        <a:buNone/>
-                      </a:pPr>
-                      <a:r>
-                        <a:rPr b="0" i="0" lang="en-US" sz="975" u="none" cap="none" strike="noStrike">
-                          <a:solidFill>
-                            <a:srgbClr val="000000"/>
-                          </a:solidFill>
-                          <a:latin typeface="Montserrat"/>
-                          <a:ea typeface="Montserrat"/>
-                          <a:cs typeface="Montserrat"/>
-                          <a:sym typeface="Montserrat"/>
-                        </a:rPr>
-                        <a:t>Bouteille Carrée Élancée 750 ml</a:t>
-                      </a:r>
-                      <a:endParaRPr/>
-                    </a:p>
-                  </a:txBody>
-                  <a:tcPr marT="25400" marB="25400" marR="63500" marL="63500" anchor="ctr">
-                    <a:lnL cap="flat" cmpd="sng" w="9525">
-                      <a:solidFill>
-                        <a:srgbClr val="000000">
-                          <a:alpha val="0"/>
-                        </a:srgbClr>
-                      </a:solidFill>
-                      <a:prstDash val="solid"/>
-                      <a:round/>
-                      <a:headEnd len="sm" w="sm" type="none"/>
-                      <a:tailEnd len="sm" w="sm" type="none"/>
-                    </a:lnL>
-                    <a:lnR cap="flat" cmpd="sng" w="9525">
-                      <a:solidFill>
-                        <a:srgbClr val="000000">
-                          <a:alpha val="0"/>
-                        </a:srgbClr>
-                      </a:solidFill>
-                      <a:prstDash val="solid"/>
-                      <a:round/>
-                      <a:headEnd len="sm" w="sm" type="none"/>
-                      <a:tailEnd len="sm" w="sm" type="none"/>
-                    </a:lnR>
-                    <a:lnT cap="flat" cmpd="sng" w="9525">
-                      <a:solidFill>
-                        <a:srgbClr val="000000">
-                          <a:alpha val="0"/>
-                        </a:srgbClr>
-                      </a:solidFill>
-                      <a:prstDash val="solid"/>
-                      <a:round/>
-                      <a:headEnd len="sm" w="sm" type="none"/>
-                      <a:tailEnd len="sm" w="sm" type="none"/>
-                    </a:lnT>
-                    <a:lnB cap="flat" cmpd="sng" w="9525">
-                      <a:solidFill>
-                        <a:srgbClr val="000000">
-                          <a:alpha val="0"/>
-                        </a:srgbClr>
-                      </a:solidFill>
-                      <a:prstDash val="solid"/>
-                      <a:round/>
-                      <a:headEnd len="sm" w="sm" type="none"/>
-                      <a:tailEnd len="sm" w="sm" type="none"/>
-                    </a:lnB>
-                    <a:solidFill>
-                      <a:srgbClr val="3B533E"/>
-                    </a:solidFill>
-                  </a:tcPr>
-                </a:tc>
-                <a:tc>
-                  <a:txBody>
-                    <a:bodyPr/>
-                    <a:lstStyle/>
-                    <a:p>
-                      <a:pPr indent="0" lvl="0" marL="0" marR="0" rtl="0" algn="l">
-                        <a:spcBef>
-                          <a:spcPts val="0"/>
-                        </a:spcBef>
-                        <a:spcAft>
-                          <a:spcPts val="0"/>
-                        </a:spcAft>
-                        <a:buNone/>
-                      </a:pPr>
-                      <a:r>
-                        <a:rPr b="0" i="0" lang="en-US" sz="975" u="none" cap="none" strike="noStrike">
-                          <a:solidFill>
-                            <a:srgbClr val="000000"/>
-                          </a:solidFill>
-                          <a:latin typeface="Montserrat"/>
-                          <a:ea typeface="Montserrat"/>
-                          <a:cs typeface="Montserrat"/>
-                          <a:sym typeface="Montserrat"/>
-                        </a:rPr>
-                        <a:t>Verre Luxe</a:t>
-                      </a:r>
-                      <a:endParaRPr/>
-                    </a:p>
-                  </a:txBody>
-                  <a:tcPr marT="25400" marB="25400" marR="63500" marL="63500" anchor="ctr">
-                    <a:lnL cap="flat" cmpd="sng" w="9525">
-                      <a:solidFill>
-                        <a:srgbClr val="000000">
-                          <a:alpha val="0"/>
-                        </a:srgbClr>
-                      </a:solidFill>
-                      <a:prstDash val="solid"/>
-                      <a:round/>
-                      <a:headEnd len="sm" w="sm" type="none"/>
-                      <a:tailEnd len="sm" w="sm" type="none"/>
-                    </a:lnL>
-                    <a:lnR cap="flat" cmpd="sng" w="9525">
-                      <a:solidFill>
-                        <a:srgbClr val="000000">
-                          <a:alpha val="0"/>
-                        </a:srgbClr>
-                      </a:solidFill>
-                      <a:prstDash val="solid"/>
-                      <a:round/>
-                      <a:headEnd len="sm" w="sm" type="none"/>
-                      <a:tailEnd len="sm" w="sm" type="none"/>
-                    </a:lnR>
-                    <a:lnT cap="flat" cmpd="sng" w="9525">
-                      <a:solidFill>
-                        <a:srgbClr val="000000">
-                          <a:alpha val="0"/>
-                        </a:srgbClr>
-                      </a:solidFill>
-                      <a:prstDash val="solid"/>
-                      <a:round/>
-                      <a:headEnd len="sm" w="sm" type="none"/>
-                      <a:tailEnd len="sm" w="sm" type="none"/>
-                    </a:lnT>
-                    <a:lnB cap="flat" cmpd="sng" w="9525">
-                      <a:solidFill>
-                        <a:srgbClr val="000000">
-                          <a:alpha val="0"/>
-                        </a:srgbClr>
-                      </a:solidFill>
-                      <a:prstDash val="solid"/>
-                      <a:round/>
-                      <a:headEnd len="sm" w="sm" type="none"/>
-                      <a:tailEnd len="sm" w="sm" type="none"/>
-                    </a:lnB>
-                    <a:solidFill>
-                      <a:srgbClr val="3B533E"/>
-                    </a:solidFill>
-                  </a:tcPr>
-                </a:tc>
-                <a:tc>
-                  <a:txBody>
-                    <a:bodyPr/>
-                    <a:lstStyle/>
-                    <a:p>
-                      <a:pPr indent="0" lvl="0" marL="0" marR="0" rtl="0" algn="l">
-                        <a:spcBef>
-                          <a:spcPts val="0"/>
-                        </a:spcBef>
-                        <a:spcAft>
-                          <a:spcPts val="0"/>
-                        </a:spcAft>
-                        <a:buNone/>
-                      </a:pPr>
-                      <a:r>
-                        <a:rPr b="0" i="0" lang="en-US" sz="975" u="none" cap="none" strike="noStrike">
-                          <a:solidFill>
-                            <a:srgbClr val="000000"/>
-                          </a:solidFill>
-                          <a:latin typeface="Montserrat"/>
-                          <a:ea typeface="Montserrat"/>
-                          <a:cs typeface="Montserrat"/>
-                          <a:sym typeface="Montserrat"/>
-                        </a:rPr>
-                        <a:t>13,9 Mo</a:t>
-                      </a:r>
-                      <a:endParaRPr/>
-                    </a:p>
-                  </a:txBody>
-                  <a:tcPr marT="25400" marB="25400" marR="63500" marL="63500" anchor="ctr">
-                    <a:lnL cap="flat" cmpd="sng" w="9525">
-                      <a:solidFill>
-                        <a:srgbClr val="000000">
-                          <a:alpha val="0"/>
-                        </a:srgbClr>
-                      </a:solidFill>
-                      <a:prstDash val="solid"/>
-                      <a:round/>
-                      <a:headEnd len="sm" w="sm" type="none"/>
-                      <a:tailEnd len="sm" w="sm" type="none"/>
-                    </a:lnL>
-                    <a:lnR cap="flat" cmpd="sng" w="9525">
-                      <a:solidFill>
-                        <a:srgbClr val="000000">
-                          <a:alpha val="0"/>
-                        </a:srgbClr>
-                      </a:solidFill>
-                      <a:prstDash val="solid"/>
-                      <a:round/>
-                      <a:headEnd len="sm" w="sm" type="none"/>
-                      <a:tailEnd len="sm" w="sm" type="none"/>
-                    </a:lnR>
-                    <a:lnT cap="flat" cmpd="sng" w="9525">
-                      <a:solidFill>
-                        <a:srgbClr val="000000">
-                          <a:alpha val="0"/>
-                        </a:srgbClr>
-                      </a:solidFill>
-                      <a:prstDash val="solid"/>
-                      <a:round/>
-                      <a:headEnd len="sm" w="sm" type="none"/>
-                      <a:tailEnd len="sm" w="sm" type="none"/>
-                    </a:lnT>
-                    <a:lnB cap="flat" cmpd="sng" w="9525">
-                      <a:solidFill>
-                        <a:srgbClr val="000000">
-                          <a:alpha val="0"/>
-                        </a:srgbClr>
-                      </a:solidFill>
-                      <a:prstDash val="solid"/>
-                      <a:round/>
-                      <a:headEnd len="sm" w="sm" type="none"/>
-                      <a:tailEnd len="sm" w="sm" type="none"/>
-                    </a:lnB>
-                    <a:solidFill>
-                      <a:srgbClr val="3B533E"/>
-                    </a:solidFill>
-                  </a:tcPr>
-                </a:tc>
-                <a:tc>
-                  <a:txBody>
-                    <a:bodyPr/>
-                    <a:lstStyle/>
-                    <a:p>
-                      <a:pPr indent="0" lvl="0" marL="0" marR="0" rtl="0" algn="l">
-                        <a:spcBef>
-                          <a:spcPts val="0"/>
-                        </a:spcBef>
-                        <a:spcAft>
-                          <a:spcPts val="0"/>
-                        </a:spcAft>
-                        <a:buNone/>
-                      </a:pPr>
-                      <a:r>
-                        <a:rPr b="0" i="0" lang="en-US" sz="975" u="none" cap="none" strike="noStrike">
-                          <a:solidFill>
-                            <a:srgbClr val="000000"/>
-                          </a:solidFill>
-                          <a:latin typeface="Montserrat"/>
-                          <a:ea typeface="Montserrat"/>
-                          <a:cs typeface="Montserrat"/>
-                          <a:sym typeface="Montserrat"/>
-                        </a:rPr>
-                        <a:t>3,76 Mo</a:t>
-                      </a:r>
-                      <a:endParaRPr/>
-                    </a:p>
-                  </a:txBody>
-                  <a:tcPr marT="25400" marB="25400" marR="63500" marL="63500" anchor="ctr">
-                    <a:lnL cap="flat" cmpd="sng" w="9525">
-                      <a:solidFill>
-                        <a:srgbClr val="000000">
-                          <a:alpha val="0"/>
-                        </a:srgbClr>
-                      </a:solidFill>
-                      <a:prstDash val="solid"/>
-                      <a:round/>
-                      <a:headEnd len="sm" w="sm" type="none"/>
-                      <a:tailEnd len="sm" w="sm" type="none"/>
-                    </a:lnL>
-                    <a:lnR cap="flat" cmpd="sng" w="9525">
-                      <a:solidFill>
-                        <a:srgbClr val="000000">
-                          <a:alpha val="0"/>
-                        </a:srgbClr>
-                      </a:solidFill>
-                      <a:prstDash val="solid"/>
-                      <a:round/>
-                      <a:headEnd len="sm" w="sm" type="none"/>
-                      <a:tailEnd len="sm" w="sm" type="none"/>
-                    </a:lnR>
-                    <a:lnT cap="flat" cmpd="sng" w="9525">
-                      <a:solidFill>
-                        <a:srgbClr val="000000">
-                          <a:alpha val="0"/>
-                        </a:srgbClr>
-                      </a:solidFill>
-                      <a:prstDash val="solid"/>
-                      <a:round/>
-                      <a:headEnd len="sm" w="sm" type="none"/>
-                      <a:tailEnd len="sm" w="sm" type="none"/>
-                    </a:lnT>
-                    <a:lnB cap="flat" cmpd="sng" w="9525">
-                      <a:solidFill>
-                        <a:srgbClr val="000000">
-                          <a:alpha val="0"/>
-                        </a:srgbClr>
-                      </a:solidFill>
-                      <a:prstDash val="solid"/>
-                      <a:round/>
-                      <a:headEnd len="sm" w="sm" type="none"/>
-                      <a:tailEnd len="sm" w="sm" type="none"/>
-                    </a:lnB>
-                    <a:solidFill>
-                      <a:srgbClr val="3B533E"/>
-                    </a:solidFill>
-                  </a:tcPr>
-                </a:tc>
-                <a:tc>
-                  <a:txBody>
-                    <a:bodyPr/>
-                    <a:lstStyle/>
-                    <a:p>
-                      <a:pPr indent="0" lvl="0" marL="0" marR="0" rtl="0" algn="l">
-                        <a:spcBef>
-                          <a:spcPts val="0"/>
-                        </a:spcBef>
-                        <a:spcAft>
-                          <a:spcPts val="0"/>
-                        </a:spcAft>
-                        <a:buNone/>
-                      </a:pPr>
-                      <a:r>
-                        <a:rPr b="1" i="0" lang="en-US" sz="975" u="none" cap="none" strike="noStrike">
-                          <a:solidFill>
-                            <a:srgbClr val="000000"/>
-                          </a:solidFill>
-                          <a:latin typeface="Montserrat"/>
-                          <a:ea typeface="Montserrat"/>
-                          <a:cs typeface="Montserrat"/>
-                          <a:sym typeface="Montserrat"/>
-                        </a:rPr>
-                        <a:t>-73%</a:t>
-                      </a:r>
-                      <a:endParaRPr/>
-                    </a:p>
-                  </a:txBody>
-                  <a:tcPr marT="25400" marB="25400" marR="63500" marL="63500" anchor="ctr">
-                    <a:lnL cap="flat" cmpd="sng" w="9525">
-                      <a:solidFill>
-                        <a:srgbClr val="000000">
-                          <a:alpha val="0"/>
-                        </a:srgbClr>
-                      </a:solidFill>
-                      <a:prstDash val="solid"/>
-                      <a:round/>
-                      <a:headEnd len="sm" w="sm" type="none"/>
-                      <a:tailEnd len="sm" w="sm" type="none"/>
-                    </a:lnL>
-                    <a:lnR cap="flat" cmpd="sng" w="9525">
-                      <a:solidFill>
-                        <a:srgbClr val="000000">
-                          <a:alpha val="0"/>
-                        </a:srgbClr>
-                      </a:solidFill>
-                      <a:prstDash val="solid"/>
-                      <a:round/>
-                      <a:headEnd len="sm" w="sm" type="none"/>
-                      <a:tailEnd len="sm" w="sm" type="none"/>
-                    </a:lnR>
-                    <a:lnT cap="flat" cmpd="sng" w="9525">
-                      <a:solidFill>
-                        <a:srgbClr val="000000">
-                          <a:alpha val="0"/>
-                        </a:srgbClr>
-                      </a:solidFill>
-                      <a:prstDash val="solid"/>
-                      <a:round/>
-                      <a:headEnd len="sm" w="sm" type="none"/>
-                      <a:tailEnd len="sm" w="sm" type="none"/>
-                    </a:lnT>
-                    <a:lnB cap="flat" cmpd="sng" w="9525">
-                      <a:solidFill>
-                        <a:srgbClr val="000000">
-                          <a:alpha val="0"/>
-                        </a:srgbClr>
-                      </a:solidFill>
-                      <a:prstDash val="solid"/>
-                      <a:round/>
-                      <a:headEnd len="sm" w="sm" type="none"/>
-                      <a:tailEnd len="sm" w="sm" type="none"/>
-                    </a:lnB>
-                    <a:solidFill>
-                      <a:srgbClr val="3B533E"/>
-                    </a:solidFill>
-                  </a:tcPr>
-                </a:tc>
-                <a:tc>
-                  <a:txBody>
-                    <a:bodyPr/>
-                    <a:lstStyle/>
-                    <a:p>
-                      <a:pPr indent="0" lvl="0" marL="0" marR="0" rtl="0" algn="l">
-                        <a:spcBef>
-                          <a:spcPts val="0"/>
-                        </a:spcBef>
-                        <a:spcAft>
-                          <a:spcPts val="0"/>
-                        </a:spcAft>
-                        <a:buNone/>
-                      </a:pPr>
-                      <a:r>
-                        <a:rPr b="1" i="0" lang="en-US" sz="975" u="none" cap="none" strike="noStrike">
-                          <a:solidFill>
-                            <a:srgbClr val="3B533E"/>
-                          </a:solidFill>
-                          <a:latin typeface="Montserrat"/>
-                          <a:ea typeface="Montserrat"/>
-                          <a:cs typeface="Montserrat"/>
-                          <a:sym typeface="Montserrat"/>
-                        </a:rPr>
-                        <a:t> Validé</a:t>
-                      </a:r>
-                      <a:endParaRPr/>
-                    </a:p>
-                  </a:txBody>
-                  <a:tcPr marT="25400" marB="25400" marR="63500" marL="238125" anchor="ctr">
-                    <a:lnL cap="flat" cmpd="sng" w="9525">
-                      <a:solidFill>
-                        <a:srgbClr val="000000">
-                          <a:alpha val="0"/>
-                        </a:srgbClr>
-                      </a:solidFill>
-                      <a:prstDash val="solid"/>
-                      <a:round/>
-                      <a:headEnd len="sm" w="sm" type="none"/>
-                      <a:tailEnd len="sm" w="sm" type="none"/>
-                    </a:lnL>
-                    <a:lnR cap="flat" cmpd="sng" w="9525">
-                      <a:solidFill>
-                        <a:srgbClr val="000000">
-                          <a:alpha val="0"/>
-                        </a:srgbClr>
-                      </a:solidFill>
-                      <a:prstDash val="solid"/>
-                      <a:round/>
-                      <a:headEnd len="sm" w="sm" type="none"/>
-                      <a:tailEnd len="sm" w="sm" type="none"/>
-                    </a:lnR>
-                    <a:lnT cap="flat" cmpd="sng" w="9525">
-                      <a:solidFill>
-                        <a:srgbClr val="000000">
-                          <a:alpha val="0"/>
-                        </a:srgbClr>
-                      </a:solidFill>
-                      <a:prstDash val="solid"/>
-                      <a:round/>
-                      <a:headEnd len="sm" w="sm" type="none"/>
-                      <a:tailEnd len="sm" w="sm" type="none"/>
-                    </a:lnT>
-                    <a:lnB cap="flat" cmpd="sng" w="9525">
-                      <a:solidFill>
-                        <a:srgbClr val="000000">
-                          <a:alpha val="0"/>
-                        </a:srgbClr>
-                      </a:solidFill>
-                      <a:prstDash val="solid"/>
-                      <a:round/>
-                      <a:headEnd len="sm" w="sm" type="none"/>
-                      <a:tailEnd len="sm" w="sm" type="none"/>
-                    </a:lnB>
-                    <a:solidFill>
-                      <a:srgbClr val="3B533E"/>
-                    </a:solidFill>
-                  </a:tcPr>
-                </a:tc>
-              </a:tr>
-              <a:tr h="394325">
-                <a:tc>
-                  <a:txBody>
-                    <a:bodyPr/>
-                    <a:lstStyle/>
-                    <a:p>
-                      <a:pPr indent="0" lvl="0" marL="0" marR="0" rtl="0" algn="l">
-                        <a:spcBef>
-                          <a:spcPts val="0"/>
-                        </a:spcBef>
-                        <a:spcAft>
-                          <a:spcPts val="0"/>
-                        </a:spcAft>
-                        <a:buNone/>
-                      </a:pPr>
-                      <a:r>
-                        <a:rPr b="0" i="0" lang="en-US" sz="975" u="none" cap="none" strike="noStrike">
-                          <a:solidFill>
-                            <a:srgbClr val="000000"/>
-                          </a:solidFill>
-                          <a:latin typeface="Montserrat"/>
-                          <a:ea typeface="Montserrat"/>
-                          <a:cs typeface="Montserrat"/>
-                          <a:sym typeface="Montserrat"/>
-                        </a:rPr>
-                        <a:t>Bidon Métallique Tradition 3 L</a:t>
-                      </a:r>
-                      <a:endParaRPr/>
-                    </a:p>
-                  </a:txBody>
-                  <a:tcPr marT="25400" marB="25400" marR="63500" marL="63500" anchor="ctr">
-                    <a:lnL cap="flat" cmpd="sng" w="9525">
-                      <a:solidFill>
-                        <a:srgbClr val="000000">
-                          <a:alpha val="0"/>
-                        </a:srgbClr>
-                      </a:solidFill>
-                      <a:prstDash val="solid"/>
-                      <a:round/>
-                      <a:headEnd len="sm" w="sm" type="none"/>
-                      <a:tailEnd len="sm" w="sm" type="none"/>
-                    </a:lnL>
-                    <a:lnR cap="flat" cmpd="sng" w="9525">
-                      <a:solidFill>
-                        <a:srgbClr val="000000">
-                          <a:alpha val="0"/>
-                        </a:srgbClr>
-                      </a:solidFill>
-                      <a:prstDash val="solid"/>
-                      <a:round/>
-                      <a:headEnd len="sm" w="sm" type="none"/>
-                      <a:tailEnd len="sm" w="sm" type="none"/>
-                    </a:lnR>
-                    <a:lnT cap="flat" cmpd="sng" w="9525">
-                      <a:solidFill>
-                        <a:srgbClr val="000000">
-                          <a:alpha val="0"/>
-                        </a:srgbClr>
-                      </a:solidFill>
-                      <a:prstDash val="solid"/>
-                      <a:round/>
-                      <a:headEnd len="sm" w="sm" type="none"/>
-                      <a:tailEnd len="sm" w="sm" type="none"/>
-                    </a:lnT>
-                    <a:lnB cap="flat" cmpd="sng" w="9525">
-                      <a:solidFill>
-                        <a:srgbClr val="000000">
-                          <a:alpha val="0"/>
-                        </a:srgbClr>
-                      </a:solidFill>
-                      <a:prstDash val="solid"/>
-                      <a:round/>
-                      <a:headEnd len="sm" w="sm" type="none"/>
-                      <a:tailEnd len="sm" w="sm" type="none"/>
-                    </a:lnB>
-                  </a:tcPr>
-                </a:tc>
-                <a:tc>
-                  <a:txBody>
-                    <a:bodyPr/>
-                    <a:lstStyle/>
-                    <a:p>
-                      <a:pPr indent="0" lvl="0" marL="0" marR="0" rtl="0" algn="l">
-                        <a:spcBef>
-                          <a:spcPts val="0"/>
-                        </a:spcBef>
-                        <a:spcAft>
-                          <a:spcPts val="0"/>
-                        </a:spcAft>
-                        <a:buNone/>
-                      </a:pPr>
-                      <a:r>
-                        <a:rPr b="0" i="0" lang="en-US" sz="975" u="none" cap="none" strike="noStrike">
-                          <a:solidFill>
-                            <a:srgbClr val="000000"/>
-                          </a:solidFill>
-                          <a:latin typeface="Montserrat"/>
-                          <a:ea typeface="Montserrat"/>
-                          <a:cs typeface="Montserrat"/>
-                          <a:sym typeface="Montserrat"/>
-                        </a:rPr>
-                        <a:t>Métal Brillant</a:t>
-                      </a:r>
-                      <a:endParaRPr/>
-                    </a:p>
-                  </a:txBody>
-                  <a:tcPr marT="25400" marB="25400" marR="63500" marL="63500" anchor="ctr">
-                    <a:lnL cap="flat" cmpd="sng" w="9525">
-                      <a:solidFill>
-                        <a:srgbClr val="000000">
-                          <a:alpha val="0"/>
-                        </a:srgbClr>
-                      </a:solidFill>
-                      <a:prstDash val="solid"/>
-                      <a:round/>
-                      <a:headEnd len="sm" w="sm" type="none"/>
-                      <a:tailEnd len="sm" w="sm" type="none"/>
-                    </a:lnL>
-                    <a:lnR cap="flat" cmpd="sng" w="9525">
-                      <a:solidFill>
-                        <a:srgbClr val="000000">
-                          <a:alpha val="0"/>
-                        </a:srgbClr>
-                      </a:solidFill>
-                      <a:prstDash val="solid"/>
-                      <a:round/>
-                      <a:headEnd len="sm" w="sm" type="none"/>
-                      <a:tailEnd len="sm" w="sm" type="none"/>
-                    </a:lnR>
-                    <a:lnT cap="flat" cmpd="sng" w="9525">
-                      <a:solidFill>
-                        <a:srgbClr val="000000">
-                          <a:alpha val="0"/>
-                        </a:srgbClr>
-                      </a:solidFill>
-                      <a:prstDash val="solid"/>
-                      <a:round/>
-                      <a:headEnd len="sm" w="sm" type="none"/>
-                      <a:tailEnd len="sm" w="sm" type="none"/>
-                    </a:lnT>
-                    <a:lnB cap="flat" cmpd="sng" w="9525">
-                      <a:solidFill>
-                        <a:srgbClr val="000000">
-                          <a:alpha val="0"/>
-                        </a:srgbClr>
-                      </a:solidFill>
-                      <a:prstDash val="solid"/>
-                      <a:round/>
-                      <a:headEnd len="sm" w="sm" type="none"/>
-                      <a:tailEnd len="sm" w="sm" type="none"/>
-                    </a:lnB>
-                  </a:tcPr>
-                </a:tc>
-                <a:tc>
-                  <a:txBody>
-                    <a:bodyPr/>
-                    <a:lstStyle/>
-                    <a:p>
-                      <a:pPr indent="0" lvl="0" marL="0" marR="0" rtl="0" algn="l">
-                        <a:spcBef>
-                          <a:spcPts val="0"/>
-                        </a:spcBef>
-                        <a:spcAft>
-                          <a:spcPts val="0"/>
-                        </a:spcAft>
-                        <a:buNone/>
-                      </a:pPr>
-                      <a:r>
-                        <a:rPr b="0" i="0" lang="en-US" sz="975" u="none" cap="none" strike="noStrike">
-                          <a:solidFill>
-                            <a:srgbClr val="000000"/>
-                          </a:solidFill>
-                          <a:latin typeface="Montserrat"/>
-                          <a:ea typeface="Montserrat"/>
-                          <a:cs typeface="Montserrat"/>
-                          <a:sym typeface="Montserrat"/>
-                        </a:rPr>
-                        <a:t>18,3 Mo</a:t>
-                      </a:r>
-                      <a:endParaRPr/>
-                    </a:p>
-                  </a:txBody>
-                  <a:tcPr marT="25400" marB="25400" marR="63500" marL="63500" anchor="ctr">
-                    <a:lnL cap="flat" cmpd="sng" w="9525">
-                      <a:solidFill>
-                        <a:srgbClr val="000000">
-                          <a:alpha val="0"/>
-                        </a:srgbClr>
-                      </a:solidFill>
-                      <a:prstDash val="solid"/>
-                      <a:round/>
-                      <a:headEnd len="sm" w="sm" type="none"/>
-                      <a:tailEnd len="sm" w="sm" type="none"/>
-                    </a:lnL>
-                    <a:lnR cap="flat" cmpd="sng" w="9525">
-                      <a:solidFill>
-                        <a:srgbClr val="000000">
-                          <a:alpha val="0"/>
-                        </a:srgbClr>
-                      </a:solidFill>
-                      <a:prstDash val="solid"/>
-                      <a:round/>
-                      <a:headEnd len="sm" w="sm" type="none"/>
-                      <a:tailEnd len="sm" w="sm" type="none"/>
-                    </a:lnR>
-                    <a:lnT cap="flat" cmpd="sng" w="9525">
-                      <a:solidFill>
-                        <a:srgbClr val="000000">
-                          <a:alpha val="0"/>
-                        </a:srgbClr>
-                      </a:solidFill>
-                      <a:prstDash val="solid"/>
-                      <a:round/>
-                      <a:headEnd len="sm" w="sm" type="none"/>
-                      <a:tailEnd len="sm" w="sm" type="none"/>
-                    </a:lnT>
-                    <a:lnB cap="flat" cmpd="sng" w="9525">
-                      <a:solidFill>
-                        <a:srgbClr val="000000">
-                          <a:alpha val="0"/>
-                        </a:srgbClr>
-                      </a:solidFill>
-                      <a:prstDash val="solid"/>
-                      <a:round/>
-                      <a:headEnd len="sm" w="sm" type="none"/>
-                      <a:tailEnd len="sm" w="sm" type="none"/>
-                    </a:lnB>
-                  </a:tcPr>
-                </a:tc>
-                <a:tc>
-                  <a:txBody>
-                    <a:bodyPr/>
-                    <a:lstStyle/>
-                    <a:p>
-                      <a:pPr indent="0" lvl="0" marL="0" marR="0" rtl="0" algn="l">
-                        <a:spcBef>
-                          <a:spcPts val="0"/>
-                        </a:spcBef>
-                        <a:spcAft>
-                          <a:spcPts val="0"/>
-                        </a:spcAft>
-                        <a:buNone/>
-                      </a:pPr>
-                      <a:r>
-                        <a:rPr b="0" i="0" lang="en-US" sz="975" u="none" cap="none" strike="noStrike">
-                          <a:solidFill>
-                            <a:srgbClr val="000000"/>
-                          </a:solidFill>
-                          <a:latin typeface="Montserrat"/>
-                          <a:ea typeface="Montserrat"/>
-                          <a:cs typeface="Montserrat"/>
-                          <a:sym typeface="Montserrat"/>
-                        </a:rPr>
-                        <a:t>3,56 Mo</a:t>
-                      </a:r>
-                      <a:endParaRPr/>
-                    </a:p>
-                  </a:txBody>
-                  <a:tcPr marT="25400" marB="25400" marR="63500" marL="63500" anchor="ctr">
-                    <a:lnL cap="flat" cmpd="sng" w="9525">
-                      <a:solidFill>
-                        <a:srgbClr val="000000">
-                          <a:alpha val="0"/>
-                        </a:srgbClr>
-                      </a:solidFill>
-                      <a:prstDash val="solid"/>
-                      <a:round/>
-                      <a:headEnd len="sm" w="sm" type="none"/>
-                      <a:tailEnd len="sm" w="sm" type="none"/>
-                    </a:lnL>
-                    <a:lnR cap="flat" cmpd="sng" w="9525">
-                      <a:solidFill>
-                        <a:srgbClr val="000000">
-                          <a:alpha val="0"/>
-                        </a:srgbClr>
-                      </a:solidFill>
-                      <a:prstDash val="solid"/>
-                      <a:round/>
-                      <a:headEnd len="sm" w="sm" type="none"/>
-                      <a:tailEnd len="sm" w="sm" type="none"/>
-                    </a:lnR>
-                    <a:lnT cap="flat" cmpd="sng" w="9525">
-                      <a:solidFill>
-                        <a:srgbClr val="000000">
-                          <a:alpha val="0"/>
-                        </a:srgbClr>
-                      </a:solidFill>
-                      <a:prstDash val="solid"/>
-                      <a:round/>
-                      <a:headEnd len="sm" w="sm" type="none"/>
-                      <a:tailEnd len="sm" w="sm" type="none"/>
-                    </a:lnT>
-                    <a:lnB cap="flat" cmpd="sng" w="9525">
-                      <a:solidFill>
-                        <a:srgbClr val="000000">
-                          <a:alpha val="0"/>
-                        </a:srgbClr>
-                      </a:solidFill>
-                      <a:prstDash val="solid"/>
-                      <a:round/>
-                      <a:headEnd len="sm" w="sm" type="none"/>
-                      <a:tailEnd len="sm" w="sm" type="none"/>
-                    </a:lnB>
-                  </a:tcPr>
-                </a:tc>
-                <a:tc>
-                  <a:txBody>
-                    <a:bodyPr/>
-                    <a:lstStyle/>
-                    <a:p>
-                      <a:pPr indent="0" lvl="0" marL="0" marR="0" rtl="0" algn="l">
-                        <a:spcBef>
-                          <a:spcPts val="0"/>
-                        </a:spcBef>
-                        <a:spcAft>
-                          <a:spcPts val="0"/>
-                        </a:spcAft>
-                        <a:buNone/>
-                      </a:pPr>
-                      <a:r>
-                        <a:rPr b="1" i="0" lang="en-US" sz="975" u="none" cap="none" strike="noStrike">
-                          <a:solidFill>
-                            <a:srgbClr val="000000"/>
-                          </a:solidFill>
-                          <a:latin typeface="Montserrat"/>
-                          <a:ea typeface="Montserrat"/>
-                          <a:cs typeface="Montserrat"/>
-                          <a:sym typeface="Montserrat"/>
-                        </a:rPr>
-                        <a:t>-81%</a:t>
-                      </a:r>
-                      <a:endParaRPr/>
-                    </a:p>
-                  </a:txBody>
-                  <a:tcPr marT="25400" marB="25400" marR="63500" marL="63500" anchor="ctr">
-                    <a:lnL cap="flat" cmpd="sng" w="9525">
-                      <a:solidFill>
-                        <a:srgbClr val="000000">
-                          <a:alpha val="0"/>
-                        </a:srgbClr>
-                      </a:solidFill>
-                      <a:prstDash val="solid"/>
-                      <a:round/>
-                      <a:headEnd len="sm" w="sm" type="none"/>
-                      <a:tailEnd len="sm" w="sm" type="none"/>
-                    </a:lnL>
-                    <a:lnR cap="flat" cmpd="sng" w="9525">
-                      <a:solidFill>
-                        <a:srgbClr val="000000">
-                          <a:alpha val="0"/>
-                        </a:srgbClr>
-                      </a:solidFill>
-                      <a:prstDash val="solid"/>
-                      <a:round/>
-                      <a:headEnd len="sm" w="sm" type="none"/>
-                      <a:tailEnd len="sm" w="sm" type="none"/>
-                    </a:lnR>
-                    <a:lnT cap="flat" cmpd="sng" w="9525">
-                      <a:solidFill>
-                        <a:srgbClr val="000000">
-                          <a:alpha val="0"/>
-                        </a:srgbClr>
-                      </a:solidFill>
-                      <a:prstDash val="solid"/>
-                      <a:round/>
-                      <a:headEnd len="sm" w="sm" type="none"/>
-                      <a:tailEnd len="sm" w="sm" type="none"/>
-                    </a:lnT>
-                    <a:lnB cap="flat" cmpd="sng" w="9525">
-                      <a:solidFill>
-                        <a:srgbClr val="000000">
-                          <a:alpha val="0"/>
-                        </a:srgbClr>
-                      </a:solidFill>
-                      <a:prstDash val="solid"/>
-                      <a:round/>
-                      <a:headEnd len="sm" w="sm" type="none"/>
-                      <a:tailEnd len="sm" w="sm" type="none"/>
-                    </a:lnB>
-                  </a:tcPr>
-                </a:tc>
-                <a:tc>
-                  <a:txBody>
-                    <a:bodyPr/>
-                    <a:lstStyle/>
-                    <a:p>
-                      <a:pPr indent="0" lvl="0" marL="0" marR="0" rtl="0" algn="l">
-                        <a:spcBef>
-                          <a:spcPts val="0"/>
-                        </a:spcBef>
-                        <a:spcAft>
-                          <a:spcPts val="0"/>
-                        </a:spcAft>
-                        <a:buNone/>
-                      </a:pPr>
-                      <a:r>
-                        <a:rPr b="1" i="0" lang="en-US" sz="975" u="none" cap="none" strike="noStrike">
-                          <a:solidFill>
-                            <a:srgbClr val="3B533E"/>
-                          </a:solidFill>
-                          <a:latin typeface="Montserrat"/>
-                          <a:ea typeface="Montserrat"/>
-                          <a:cs typeface="Montserrat"/>
-                          <a:sym typeface="Montserrat"/>
-                        </a:rPr>
-                        <a:t> Validé</a:t>
-                      </a:r>
-                      <a:endParaRPr/>
-                    </a:p>
-                  </a:txBody>
-                  <a:tcPr marT="25400" marB="25400" marR="63500" marL="238125" anchor="ctr">
-                    <a:lnL cap="flat" cmpd="sng" w="9525">
-                      <a:solidFill>
-                        <a:srgbClr val="000000">
-                          <a:alpha val="0"/>
-                        </a:srgbClr>
-                      </a:solidFill>
-                      <a:prstDash val="solid"/>
-                      <a:round/>
-                      <a:headEnd len="sm" w="sm" type="none"/>
-                      <a:tailEnd len="sm" w="sm" type="none"/>
-                    </a:lnL>
-                    <a:lnR cap="flat" cmpd="sng" w="9525">
-                      <a:solidFill>
-                        <a:srgbClr val="000000">
-                          <a:alpha val="0"/>
-                        </a:srgbClr>
-                      </a:solidFill>
-                      <a:prstDash val="solid"/>
-                      <a:round/>
-                      <a:headEnd len="sm" w="sm" type="none"/>
-                      <a:tailEnd len="sm" w="sm" type="none"/>
-                    </a:lnR>
-                    <a:lnT cap="flat" cmpd="sng" w="9525">
-                      <a:solidFill>
-                        <a:srgbClr val="000000">
-                          <a:alpha val="0"/>
-                        </a:srgbClr>
-                      </a:solidFill>
-                      <a:prstDash val="solid"/>
-                      <a:round/>
-                      <a:headEnd len="sm" w="sm" type="none"/>
-                      <a:tailEnd len="sm" w="sm" type="none"/>
-                    </a:lnT>
-                    <a:lnB cap="flat" cmpd="sng" w="9525">
-                      <a:solidFill>
-                        <a:srgbClr val="000000">
-                          <a:alpha val="0"/>
-                        </a:srgbClr>
-                      </a:solidFill>
-                      <a:prstDash val="solid"/>
-                      <a:round/>
-                      <a:headEnd len="sm" w="sm" type="none"/>
-                      <a:tailEnd len="sm" w="sm" type="none"/>
-                    </a:lnB>
-                  </a:tcPr>
-                </a:tc>
-              </a:tr>
-              <a:tr h="394325">
-                <a:tc>
-                  <a:txBody>
-                    <a:bodyPr/>
-                    <a:lstStyle/>
-                    <a:p>
-                      <a:pPr indent="0" lvl="0" marL="0" marR="0" rtl="0" algn="l">
-                        <a:spcBef>
-                          <a:spcPts val="0"/>
-                        </a:spcBef>
-                        <a:spcAft>
-                          <a:spcPts val="0"/>
-                        </a:spcAft>
-                        <a:buNone/>
-                      </a:pPr>
-                      <a:r>
-                        <a:rPr b="0" i="0" lang="en-US" sz="975" u="none" cap="none" strike="noStrike">
-                          <a:solidFill>
-                            <a:srgbClr val="000000"/>
-                          </a:solidFill>
-                          <a:latin typeface="Montserrat"/>
-                          <a:ea typeface="Montserrat"/>
-                          <a:cs typeface="Montserrat"/>
-                          <a:sym typeface="Montserrat"/>
-                        </a:rPr>
-                        <a:t>Bidon Vert Écologique 1 L</a:t>
-                      </a:r>
-                      <a:endParaRPr/>
-                    </a:p>
-                  </a:txBody>
-                  <a:tcPr marT="25400" marB="25400" marR="63500" marL="63500" anchor="ctr">
-                    <a:lnL cap="flat" cmpd="sng" w="9525">
-                      <a:solidFill>
-                        <a:srgbClr val="000000">
-                          <a:alpha val="0"/>
-                        </a:srgbClr>
-                      </a:solidFill>
-                      <a:prstDash val="solid"/>
-                      <a:round/>
-                      <a:headEnd len="sm" w="sm" type="none"/>
-                      <a:tailEnd len="sm" w="sm" type="none"/>
-                    </a:lnL>
-                    <a:lnR cap="flat" cmpd="sng" w="9525">
-                      <a:solidFill>
-                        <a:srgbClr val="000000">
-                          <a:alpha val="0"/>
-                        </a:srgbClr>
-                      </a:solidFill>
-                      <a:prstDash val="solid"/>
-                      <a:round/>
-                      <a:headEnd len="sm" w="sm" type="none"/>
-                      <a:tailEnd len="sm" w="sm" type="none"/>
-                    </a:lnR>
-                    <a:lnT cap="flat" cmpd="sng" w="9525">
-                      <a:solidFill>
-                        <a:srgbClr val="000000">
-                          <a:alpha val="0"/>
-                        </a:srgbClr>
-                      </a:solidFill>
-                      <a:prstDash val="solid"/>
-                      <a:round/>
-                      <a:headEnd len="sm" w="sm" type="none"/>
-                      <a:tailEnd len="sm" w="sm" type="none"/>
-                    </a:lnT>
-                    <a:lnB cap="flat" cmpd="sng" w="9525">
-                      <a:solidFill>
-                        <a:srgbClr val="000000">
-                          <a:alpha val="0"/>
-                        </a:srgbClr>
-                      </a:solidFill>
-                      <a:prstDash val="solid"/>
-                      <a:round/>
-                      <a:headEnd len="sm" w="sm" type="none"/>
-                      <a:tailEnd len="sm" w="sm" type="none"/>
-                    </a:lnB>
-                    <a:solidFill>
-                      <a:srgbClr val="3B533E"/>
-                    </a:solidFill>
-                  </a:tcPr>
-                </a:tc>
-                <a:tc>
-                  <a:txBody>
-                    <a:bodyPr/>
-                    <a:lstStyle/>
-                    <a:p>
-                      <a:pPr indent="0" lvl="0" marL="0" marR="0" rtl="0" algn="l">
-                        <a:spcBef>
-                          <a:spcPts val="0"/>
-                        </a:spcBef>
-                        <a:spcAft>
-                          <a:spcPts val="0"/>
-                        </a:spcAft>
-                        <a:buNone/>
-                      </a:pPr>
-                      <a:r>
-                        <a:rPr b="0" i="0" lang="en-US" sz="975" u="none" cap="none" strike="noStrike">
-                          <a:solidFill>
-                            <a:srgbClr val="000000"/>
-                          </a:solidFill>
-                          <a:latin typeface="Montserrat"/>
-                          <a:ea typeface="Montserrat"/>
-                          <a:cs typeface="Montserrat"/>
-                          <a:sym typeface="Montserrat"/>
-                        </a:rPr>
-                        <a:t>Bio Protégé</a:t>
-                      </a:r>
-                      <a:endParaRPr/>
-                    </a:p>
-                  </a:txBody>
-                  <a:tcPr marT="25400" marB="25400" marR="63500" marL="63500" anchor="ctr">
-                    <a:lnL cap="flat" cmpd="sng" w="9525">
-                      <a:solidFill>
-                        <a:srgbClr val="000000">
-                          <a:alpha val="0"/>
-                        </a:srgbClr>
-                      </a:solidFill>
-                      <a:prstDash val="solid"/>
-                      <a:round/>
-                      <a:headEnd len="sm" w="sm" type="none"/>
-                      <a:tailEnd len="sm" w="sm" type="none"/>
-                    </a:lnL>
-                    <a:lnR cap="flat" cmpd="sng" w="9525">
-                      <a:solidFill>
-                        <a:srgbClr val="000000">
-                          <a:alpha val="0"/>
-                        </a:srgbClr>
-                      </a:solidFill>
-                      <a:prstDash val="solid"/>
-                      <a:round/>
-                      <a:headEnd len="sm" w="sm" type="none"/>
-                      <a:tailEnd len="sm" w="sm" type="none"/>
-                    </a:lnR>
-                    <a:lnT cap="flat" cmpd="sng" w="9525">
-                      <a:solidFill>
-                        <a:srgbClr val="000000">
-                          <a:alpha val="0"/>
-                        </a:srgbClr>
-                      </a:solidFill>
-                      <a:prstDash val="solid"/>
-                      <a:round/>
-                      <a:headEnd len="sm" w="sm" type="none"/>
-                      <a:tailEnd len="sm" w="sm" type="none"/>
-                    </a:lnT>
-                    <a:lnB cap="flat" cmpd="sng" w="9525">
-                      <a:solidFill>
-                        <a:srgbClr val="000000">
-                          <a:alpha val="0"/>
-                        </a:srgbClr>
-                      </a:solidFill>
-                      <a:prstDash val="solid"/>
-                      <a:round/>
-                      <a:headEnd len="sm" w="sm" type="none"/>
-                      <a:tailEnd len="sm" w="sm" type="none"/>
-                    </a:lnB>
-                    <a:solidFill>
-                      <a:srgbClr val="3B533E"/>
-                    </a:solidFill>
-                  </a:tcPr>
-                </a:tc>
-                <a:tc>
-                  <a:txBody>
-                    <a:bodyPr/>
-                    <a:lstStyle/>
-                    <a:p>
-                      <a:pPr indent="0" lvl="0" marL="0" marR="0" rtl="0" algn="l">
-                        <a:spcBef>
-                          <a:spcPts val="0"/>
-                        </a:spcBef>
-                        <a:spcAft>
-                          <a:spcPts val="0"/>
-                        </a:spcAft>
-                        <a:buNone/>
-                      </a:pPr>
-                      <a:r>
-                        <a:rPr b="0" i="0" lang="en-US" sz="975" u="none" cap="none" strike="noStrike">
-                          <a:solidFill>
-                            <a:srgbClr val="000000"/>
-                          </a:solidFill>
-                          <a:latin typeface="Montserrat"/>
-                          <a:ea typeface="Montserrat"/>
-                          <a:cs typeface="Montserrat"/>
-                          <a:sym typeface="Montserrat"/>
-                        </a:rPr>
-                        <a:t>8,75 Mo</a:t>
-                      </a:r>
-                      <a:endParaRPr/>
-                    </a:p>
-                  </a:txBody>
-                  <a:tcPr marT="25400" marB="25400" marR="63500" marL="63500" anchor="ctr">
-                    <a:lnL cap="flat" cmpd="sng" w="9525">
-                      <a:solidFill>
-                        <a:srgbClr val="000000">
-                          <a:alpha val="0"/>
-                        </a:srgbClr>
-                      </a:solidFill>
-                      <a:prstDash val="solid"/>
-                      <a:round/>
-                      <a:headEnd len="sm" w="sm" type="none"/>
-                      <a:tailEnd len="sm" w="sm" type="none"/>
-                    </a:lnL>
-                    <a:lnR cap="flat" cmpd="sng" w="9525">
-                      <a:solidFill>
-                        <a:srgbClr val="000000">
-                          <a:alpha val="0"/>
-                        </a:srgbClr>
-                      </a:solidFill>
-                      <a:prstDash val="solid"/>
-                      <a:round/>
-                      <a:headEnd len="sm" w="sm" type="none"/>
-                      <a:tailEnd len="sm" w="sm" type="none"/>
-                    </a:lnR>
-                    <a:lnT cap="flat" cmpd="sng" w="9525">
-                      <a:solidFill>
-                        <a:srgbClr val="000000">
-                          <a:alpha val="0"/>
-                        </a:srgbClr>
-                      </a:solidFill>
-                      <a:prstDash val="solid"/>
-                      <a:round/>
-                      <a:headEnd len="sm" w="sm" type="none"/>
-                      <a:tailEnd len="sm" w="sm" type="none"/>
-                    </a:lnT>
-                    <a:lnB cap="flat" cmpd="sng" w="9525">
-                      <a:solidFill>
-                        <a:srgbClr val="000000">
-                          <a:alpha val="0"/>
-                        </a:srgbClr>
-                      </a:solidFill>
-                      <a:prstDash val="solid"/>
-                      <a:round/>
-                      <a:headEnd len="sm" w="sm" type="none"/>
-                      <a:tailEnd len="sm" w="sm" type="none"/>
-                    </a:lnB>
-                    <a:solidFill>
-                      <a:srgbClr val="3B533E"/>
-                    </a:solidFill>
-                  </a:tcPr>
-                </a:tc>
-                <a:tc>
-                  <a:txBody>
-                    <a:bodyPr/>
-                    <a:lstStyle/>
-                    <a:p>
-                      <a:pPr indent="0" lvl="0" marL="0" marR="0" rtl="0" algn="l">
-                        <a:spcBef>
-                          <a:spcPts val="0"/>
-                        </a:spcBef>
-                        <a:spcAft>
-                          <a:spcPts val="0"/>
-                        </a:spcAft>
-                        <a:buNone/>
-                      </a:pPr>
-                      <a:r>
-                        <a:rPr b="0" i="0" lang="en-US" sz="975" u="none" cap="none" strike="noStrike">
-                          <a:solidFill>
-                            <a:srgbClr val="000000"/>
-                          </a:solidFill>
-                          <a:latin typeface="Montserrat"/>
-                          <a:ea typeface="Montserrat"/>
-                          <a:cs typeface="Montserrat"/>
-                          <a:sym typeface="Montserrat"/>
-                        </a:rPr>
-                        <a:t>3,87 Mo</a:t>
-                      </a:r>
-                      <a:endParaRPr/>
-                    </a:p>
-                  </a:txBody>
-                  <a:tcPr marT="25400" marB="25400" marR="63500" marL="63500" anchor="ctr">
-                    <a:lnL cap="flat" cmpd="sng" w="9525">
-                      <a:solidFill>
-                        <a:srgbClr val="000000">
-                          <a:alpha val="0"/>
-                        </a:srgbClr>
-                      </a:solidFill>
-                      <a:prstDash val="solid"/>
-                      <a:round/>
-                      <a:headEnd len="sm" w="sm" type="none"/>
-                      <a:tailEnd len="sm" w="sm" type="none"/>
-                    </a:lnL>
-                    <a:lnR cap="flat" cmpd="sng" w="9525">
-                      <a:solidFill>
-                        <a:srgbClr val="000000">
-                          <a:alpha val="0"/>
-                        </a:srgbClr>
-                      </a:solidFill>
-                      <a:prstDash val="solid"/>
-                      <a:round/>
-                      <a:headEnd len="sm" w="sm" type="none"/>
-                      <a:tailEnd len="sm" w="sm" type="none"/>
-                    </a:lnR>
-                    <a:lnT cap="flat" cmpd="sng" w="9525">
-                      <a:solidFill>
-                        <a:srgbClr val="000000">
-                          <a:alpha val="0"/>
-                        </a:srgbClr>
-                      </a:solidFill>
-                      <a:prstDash val="solid"/>
-                      <a:round/>
-                      <a:headEnd len="sm" w="sm" type="none"/>
-                      <a:tailEnd len="sm" w="sm" type="none"/>
-                    </a:lnT>
-                    <a:lnB cap="flat" cmpd="sng" w="9525">
-                      <a:solidFill>
-                        <a:srgbClr val="000000">
-                          <a:alpha val="0"/>
-                        </a:srgbClr>
-                      </a:solidFill>
-                      <a:prstDash val="solid"/>
-                      <a:round/>
-                      <a:headEnd len="sm" w="sm" type="none"/>
-                      <a:tailEnd len="sm" w="sm" type="none"/>
-                    </a:lnB>
-                    <a:solidFill>
-                      <a:srgbClr val="3B533E"/>
-                    </a:solidFill>
-                  </a:tcPr>
-                </a:tc>
-                <a:tc>
-                  <a:txBody>
-                    <a:bodyPr/>
-                    <a:lstStyle/>
-                    <a:p>
-                      <a:pPr indent="0" lvl="0" marL="0" marR="0" rtl="0" algn="l">
-                        <a:spcBef>
-                          <a:spcPts val="0"/>
-                        </a:spcBef>
-                        <a:spcAft>
-                          <a:spcPts val="0"/>
-                        </a:spcAft>
-                        <a:buNone/>
-                      </a:pPr>
-                      <a:r>
-                        <a:rPr b="1" i="0" lang="en-US" sz="975" u="none" cap="none" strike="noStrike">
-                          <a:solidFill>
-                            <a:srgbClr val="000000"/>
-                          </a:solidFill>
-                          <a:latin typeface="Montserrat"/>
-                          <a:ea typeface="Montserrat"/>
-                          <a:cs typeface="Montserrat"/>
-                          <a:sym typeface="Montserrat"/>
-                        </a:rPr>
-                        <a:t>-56%</a:t>
-                      </a:r>
-                      <a:endParaRPr/>
-                    </a:p>
-                  </a:txBody>
-                  <a:tcPr marT="25400" marB="25400" marR="63500" marL="63500" anchor="ctr">
-                    <a:lnL cap="flat" cmpd="sng" w="9525">
-                      <a:solidFill>
-                        <a:srgbClr val="000000">
-                          <a:alpha val="0"/>
-                        </a:srgbClr>
-                      </a:solidFill>
-                      <a:prstDash val="solid"/>
-                      <a:round/>
-                      <a:headEnd len="sm" w="sm" type="none"/>
-                      <a:tailEnd len="sm" w="sm" type="none"/>
-                    </a:lnL>
-                    <a:lnR cap="flat" cmpd="sng" w="9525">
-                      <a:solidFill>
-                        <a:srgbClr val="000000">
-                          <a:alpha val="0"/>
-                        </a:srgbClr>
-                      </a:solidFill>
-                      <a:prstDash val="solid"/>
-                      <a:round/>
-                      <a:headEnd len="sm" w="sm" type="none"/>
-                      <a:tailEnd len="sm" w="sm" type="none"/>
-                    </a:lnR>
-                    <a:lnT cap="flat" cmpd="sng" w="9525">
-                      <a:solidFill>
-                        <a:srgbClr val="000000">
-                          <a:alpha val="0"/>
-                        </a:srgbClr>
-                      </a:solidFill>
-                      <a:prstDash val="solid"/>
-                      <a:round/>
-                      <a:headEnd len="sm" w="sm" type="none"/>
-                      <a:tailEnd len="sm" w="sm" type="none"/>
-                    </a:lnT>
-                    <a:lnB cap="flat" cmpd="sng" w="9525">
-                      <a:solidFill>
-                        <a:srgbClr val="000000">
-                          <a:alpha val="0"/>
-                        </a:srgbClr>
-                      </a:solidFill>
-                      <a:prstDash val="solid"/>
-                      <a:round/>
-                      <a:headEnd len="sm" w="sm" type="none"/>
-                      <a:tailEnd len="sm" w="sm" type="none"/>
-                    </a:lnB>
-                    <a:solidFill>
-                      <a:srgbClr val="3B533E"/>
-                    </a:solidFill>
-                  </a:tcPr>
-                </a:tc>
-                <a:tc>
-                  <a:txBody>
-                    <a:bodyPr/>
-                    <a:lstStyle/>
-                    <a:p>
-                      <a:pPr indent="0" lvl="0" marL="0" marR="0" rtl="0" algn="l">
-                        <a:spcBef>
-                          <a:spcPts val="0"/>
-                        </a:spcBef>
-                        <a:spcAft>
-                          <a:spcPts val="0"/>
-                        </a:spcAft>
-                        <a:buNone/>
-                      </a:pPr>
-                      <a:r>
-                        <a:rPr b="1" i="0" lang="en-US" sz="975" u="none" cap="none" strike="noStrike">
-                          <a:solidFill>
-                            <a:srgbClr val="3B533E"/>
-                          </a:solidFill>
-                          <a:latin typeface="Montserrat"/>
-                          <a:ea typeface="Montserrat"/>
-                          <a:cs typeface="Montserrat"/>
-                          <a:sym typeface="Montserrat"/>
-                        </a:rPr>
-                        <a:t> Validé</a:t>
-                      </a:r>
-                      <a:endParaRPr/>
-                    </a:p>
-                  </a:txBody>
-                  <a:tcPr marT="25400" marB="25400" marR="63500" marL="238125" anchor="ctr">
-                    <a:lnL cap="flat" cmpd="sng" w="9525">
-                      <a:solidFill>
-                        <a:srgbClr val="000000">
-                          <a:alpha val="0"/>
-                        </a:srgbClr>
-                      </a:solidFill>
-                      <a:prstDash val="solid"/>
-                      <a:round/>
-                      <a:headEnd len="sm" w="sm" type="none"/>
-                      <a:tailEnd len="sm" w="sm" type="none"/>
-                    </a:lnL>
-                    <a:lnR cap="flat" cmpd="sng" w="9525">
-                      <a:solidFill>
-                        <a:srgbClr val="000000">
-                          <a:alpha val="0"/>
-                        </a:srgbClr>
-                      </a:solidFill>
-                      <a:prstDash val="solid"/>
-                      <a:round/>
-                      <a:headEnd len="sm" w="sm" type="none"/>
-                      <a:tailEnd len="sm" w="sm" type="none"/>
-                    </a:lnR>
-                    <a:lnT cap="flat" cmpd="sng" w="9525">
-                      <a:solidFill>
-                        <a:srgbClr val="000000">
-                          <a:alpha val="0"/>
-                        </a:srgbClr>
-                      </a:solidFill>
-                      <a:prstDash val="solid"/>
-                      <a:round/>
-                      <a:headEnd len="sm" w="sm" type="none"/>
-                      <a:tailEnd len="sm" w="sm" type="none"/>
-                    </a:lnT>
-                    <a:lnB cap="flat" cmpd="sng" w="9525">
-                      <a:solidFill>
-                        <a:srgbClr val="000000">
-                          <a:alpha val="0"/>
-                        </a:srgbClr>
-                      </a:solidFill>
-                      <a:prstDash val="solid"/>
-                      <a:round/>
-                      <a:headEnd len="sm" w="sm" type="none"/>
-                      <a:tailEnd len="sm" w="sm" type="none"/>
-                    </a:lnB>
-                    <a:solidFill>
-                      <a:srgbClr val="3B533E"/>
-                    </a:solidFill>
-                  </a:tcPr>
-                </a:tc>
-              </a:tr>
-            </a:tbl>
-          </a:graphicData>
-        </a:graphic>
-      </p:graphicFrame>
-      <p:sp>
-        <p:nvSpPr>
-          <p:cNvPr id="222" name="Google Shape;222;p20"/>
-          <p:cNvSpPr/>
-          <p:nvPr/>
-        </p:nvSpPr>
-        <p:spPr>
-          <a:xfrm>
-            <a:off x="571500" y="3243262"/>
-            <a:ext cx="2638871" cy="9525"/>
-          </a:xfrm>
-          <a:prstGeom prst="rect">
-            <a:avLst/>
-          </a:prstGeom>
-          <a:solidFill>
-            <a:srgbClr val="E6E9E6"/>
-          </a:solidFill>
-          <a:ln>
-            <a:noFill/>
-          </a:ln>
-        </p:spPr>
-        <p:txBody>
-          <a:bodyPr anchorCtr="0" anchor="ctr" bIns="45700" lIns="91425" spcFirstLastPara="1" rIns="91425" wrap="square" tIns="45700">
-            <a:noAutofit/>
-          </a:bodyPr>
-          <a:lstStyle/>
-          <a:p>
-            <a:pPr indent="0" lvl="0" marL="0" marR="0" rtl="0" algn="ctr">
-              <a:spcBef>
-                <a:spcPts val="0"/>
-              </a:spcBef>
-              <a:spcAft>
-                <a:spcPts val="0"/>
-              </a:spcAft>
-              <a:buNone/>
-            </a:pPr>
-            <a:r>
-              <a:t/>
-            </a:r>
-            <a:endParaRPr b="0" i="0" sz="1800" u="none" cap="none" strike="noStrike">
-              <a:solidFill>
-                <a:schemeClr val="dk1"/>
-              </a:solidFill>
-              <a:latin typeface="Calibri"/>
-              <a:ea typeface="Calibri"/>
-              <a:cs typeface="Calibri"/>
-              <a:sym typeface="Calibri"/>
-            </a:endParaRPr>
-          </a:p>
-        </p:txBody>
-      </p:sp>
-      <p:sp>
-        <p:nvSpPr>
-          <p:cNvPr id="223" name="Google Shape;223;p20"/>
-          <p:cNvSpPr/>
-          <p:nvPr/>
-        </p:nvSpPr>
-        <p:spPr>
-          <a:xfrm>
-            <a:off x="3210371" y="3243262"/>
-            <a:ext cx="1458813" cy="9525"/>
-          </a:xfrm>
-          <a:prstGeom prst="rect">
-            <a:avLst/>
-          </a:prstGeom>
-          <a:solidFill>
-            <a:srgbClr val="E6E9E6"/>
-          </a:solidFill>
-          <a:ln>
-            <a:noFill/>
-          </a:ln>
-        </p:spPr>
-        <p:txBody>
-          <a:bodyPr anchorCtr="0" anchor="ctr" bIns="45700" lIns="91425" spcFirstLastPara="1" rIns="91425" wrap="square" tIns="45700">
-            <a:noAutofit/>
-          </a:bodyPr>
-          <a:lstStyle/>
-          <a:p>
-            <a:pPr indent="0" lvl="0" marL="0" marR="0" rtl="0" algn="ctr">
-              <a:spcBef>
-                <a:spcPts val="0"/>
-              </a:spcBef>
-              <a:spcAft>
-                <a:spcPts val="0"/>
-              </a:spcAft>
-              <a:buNone/>
-            </a:pPr>
-            <a:r>
-              <a:t/>
-            </a:r>
-            <a:endParaRPr b="0" i="0" sz="1800" u="none" cap="none" strike="noStrike">
-              <a:solidFill>
-                <a:schemeClr val="dk1"/>
-              </a:solidFill>
-              <a:latin typeface="Calibri"/>
-              <a:ea typeface="Calibri"/>
-              <a:cs typeface="Calibri"/>
-              <a:sym typeface="Calibri"/>
-            </a:endParaRPr>
-          </a:p>
-        </p:txBody>
-      </p:sp>
-      <p:sp>
-        <p:nvSpPr>
-          <p:cNvPr id="224" name="Google Shape;224;p20"/>
-          <p:cNvSpPr/>
-          <p:nvPr/>
-        </p:nvSpPr>
-        <p:spPr>
-          <a:xfrm>
-            <a:off x="4669184" y="3243262"/>
-            <a:ext cx="1372939" cy="9525"/>
-          </a:xfrm>
-          <a:prstGeom prst="rect">
-            <a:avLst/>
-          </a:prstGeom>
-          <a:solidFill>
-            <a:srgbClr val="E6E9E6"/>
-          </a:solidFill>
-          <a:ln>
-            <a:noFill/>
-          </a:ln>
-        </p:spPr>
-        <p:txBody>
-          <a:bodyPr anchorCtr="0" anchor="ctr" bIns="45700" lIns="91425" spcFirstLastPara="1" rIns="91425" wrap="square" tIns="45700">
-            <a:noAutofit/>
-          </a:bodyPr>
-          <a:lstStyle/>
-          <a:p>
-            <a:pPr indent="0" lvl="0" marL="0" marR="0" rtl="0" algn="ctr">
-              <a:spcBef>
-                <a:spcPts val="0"/>
-              </a:spcBef>
-              <a:spcAft>
-                <a:spcPts val="0"/>
-              </a:spcAft>
-              <a:buNone/>
-            </a:pPr>
-            <a:r>
-              <a:t/>
-            </a:r>
-            <a:endParaRPr b="0" i="0" sz="1800" u="none" cap="none" strike="noStrike">
-              <a:solidFill>
-                <a:schemeClr val="dk1"/>
-              </a:solidFill>
-              <a:latin typeface="Calibri"/>
-              <a:ea typeface="Calibri"/>
-              <a:cs typeface="Calibri"/>
-              <a:sym typeface="Calibri"/>
-            </a:endParaRPr>
-          </a:p>
-        </p:txBody>
-      </p:sp>
-      <p:sp>
-        <p:nvSpPr>
-          <p:cNvPr id="225" name="Google Shape;225;p20"/>
-          <p:cNvSpPr/>
-          <p:nvPr/>
-        </p:nvSpPr>
-        <p:spPr>
-          <a:xfrm>
-            <a:off x="6042124" y="3243262"/>
-            <a:ext cx="1952327" cy="9525"/>
-          </a:xfrm>
-          <a:prstGeom prst="rect">
-            <a:avLst/>
-          </a:prstGeom>
-          <a:solidFill>
-            <a:srgbClr val="E6E9E6"/>
-          </a:solidFill>
-          <a:ln>
-            <a:noFill/>
-          </a:ln>
-        </p:spPr>
-        <p:txBody>
-          <a:bodyPr anchorCtr="0" anchor="ctr" bIns="45700" lIns="91425" spcFirstLastPara="1" rIns="91425" wrap="square" tIns="45700">
-            <a:noAutofit/>
-          </a:bodyPr>
-          <a:lstStyle/>
-          <a:p>
-            <a:pPr indent="0" lvl="0" marL="0" marR="0" rtl="0" algn="ctr">
-              <a:spcBef>
-                <a:spcPts val="0"/>
-              </a:spcBef>
-              <a:spcAft>
-                <a:spcPts val="0"/>
-              </a:spcAft>
-              <a:buNone/>
-            </a:pPr>
-            <a:r>
-              <a:t/>
-            </a:r>
-            <a:endParaRPr b="0" i="0" sz="1800" u="none" cap="none" strike="noStrike">
-              <a:solidFill>
-                <a:schemeClr val="dk1"/>
-              </a:solidFill>
-              <a:latin typeface="Calibri"/>
-              <a:ea typeface="Calibri"/>
-              <a:cs typeface="Calibri"/>
-              <a:sym typeface="Calibri"/>
-            </a:endParaRPr>
-          </a:p>
-        </p:txBody>
-      </p:sp>
-      <p:sp>
-        <p:nvSpPr>
-          <p:cNvPr id="226" name="Google Shape;226;p20"/>
-          <p:cNvSpPr/>
-          <p:nvPr/>
-        </p:nvSpPr>
-        <p:spPr>
-          <a:xfrm>
-            <a:off x="7994451" y="3243262"/>
-            <a:ext cx="1877169" cy="9525"/>
-          </a:xfrm>
-          <a:prstGeom prst="rect">
-            <a:avLst/>
-          </a:prstGeom>
-          <a:solidFill>
-            <a:srgbClr val="E6E9E6"/>
-          </a:solidFill>
-          <a:ln>
-            <a:noFill/>
-          </a:ln>
-        </p:spPr>
-        <p:txBody>
-          <a:bodyPr anchorCtr="0" anchor="ctr" bIns="45700" lIns="91425" spcFirstLastPara="1" rIns="91425" wrap="square" tIns="45700">
-            <a:noAutofit/>
-          </a:bodyPr>
-          <a:lstStyle/>
-          <a:p>
-            <a:pPr indent="0" lvl="0" marL="0" marR="0" rtl="0" algn="ctr">
-              <a:spcBef>
-                <a:spcPts val="0"/>
-              </a:spcBef>
-              <a:spcAft>
-                <a:spcPts val="0"/>
-              </a:spcAft>
-              <a:buNone/>
-            </a:pPr>
-            <a:r>
-              <a:t/>
-            </a:r>
-            <a:endParaRPr b="0" i="0" sz="1800" u="none" cap="none" strike="noStrike">
-              <a:solidFill>
-                <a:schemeClr val="dk1"/>
-              </a:solidFill>
-              <a:latin typeface="Calibri"/>
-              <a:ea typeface="Calibri"/>
-              <a:cs typeface="Calibri"/>
-              <a:sym typeface="Calibri"/>
-            </a:endParaRPr>
-          </a:p>
-        </p:txBody>
-      </p:sp>
-      <p:sp>
-        <p:nvSpPr>
-          <p:cNvPr id="227" name="Google Shape;227;p20"/>
-          <p:cNvSpPr/>
-          <p:nvPr/>
-        </p:nvSpPr>
-        <p:spPr>
-          <a:xfrm>
-            <a:off x="9871620" y="3243262"/>
-            <a:ext cx="1748879" cy="9525"/>
-          </a:xfrm>
-          <a:prstGeom prst="rect">
-            <a:avLst/>
-          </a:prstGeom>
-          <a:solidFill>
-            <a:srgbClr val="E6E9E6"/>
-          </a:solidFill>
-          <a:ln>
-            <a:noFill/>
-          </a:ln>
-        </p:spPr>
-        <p:txBody>
-          <a:bodyPr anchorCtr="0" anchor="ctr" bIns="45700" lIns="91425" spcFirstLastPara="1" rIns="91425" wrap="square" tIns="45700">
-            <a:noAutofit/>
-          </a:bodyPr>
-          <a:lstStyle/>
-          <a:p>
-            <a:pPr indent="0" lvl="0" marL="0" marR="0" rtl="0" algn="ctr">
-              <a:spcBef>
-                <a:spcPts val="0"/>
-              </a:spcBef>
-              <a:spcAft>
-                <a:spcPts val="0"/>
-              </a:spcAft>
-              <a:buNone/>
-            </a:pPr>
-            <a:r>
-              <a:t/>
-            </a:r>
-            <a:endParaRPr b="0" i="0" sz="1800" u="none" cap="none" strike="noStrike">
-              <a:solidFill>
-                <a:schemeClr val="dk1"/>
-              </a:solidFill>
-              <a:latin typeface="Calibri"/>
-              <a:ea typeface="Calibri"/>
-              <a:cs typeface="Calibri"/>
-              <a:sym typeface="Calibri"/>
-            </a:endParaRPr>
-          </a:p>
-        </p:txBody>
-      </p:sp>
-      <p:sp>
-        <p:nvSpPr>
-          <p:cNvPr id="228" name="Google Shape;228;p20"/>
-          <p:cNvSpPr/>
-          <p:nvPr/>
-        </p:nvSpPr>
-        <p:spPr>
-          <a:xfrm>
-            <a:off x="571500" y="3633787"/>
-            <a:ext cx="2638871" cy="9525"/>
-          </a:xfrm>
-          <a:prstGeom prst="rect">
-            <a:avLst/>
-          </a:prstGeom>
-          <a:solidFill>
-            <a:srgbClr val="E6E9E6"/>
-          </a:solidFill>
-          <a:ln>
-            <a:noFill/>
-          </a:ln>
-        </p:spPr>
-        <p:txBody>
-          <a:bodyPr anchorCtr="0" anchor="ctr" bIns="45700" lIns="91425" spcFirstLastPara="1" rIns="91425" wrap="square" tIns="45700">
-            <a:noAutofit/>
-          </a:bodyPr>
-          <a:lstStyle/>
-          <a:p>
-            <a:pPr indent="0" lvl="0" marL="0" marR="0" rtl="0" algn="ctr">
-              <a:spcBef>
-                <a:spcPts val="0"/>
-              </a:spcBef>
-              <a:spcAft>
-                <a:spcPts val="0"/>
-              </a:spcAft>
-              <a:buNone/>
-            </a:pPr>
-            <a:r>
-              <a:t/>
-            </a:r>
-            <a:endParaRPr b="0" i="0" sz="1800" u="none" cap="none" strike="noStrike">
-              <a:solidFill>
-                <a:schemeClr val="dk1"/>
-              </a:solidFill>
-              <a:latin typeface="Calibri"/>
-              <a:ea typeface="Calibri"/>
-              <a:cs typeface="Calibri"/>
-              <a:sym typeface="Calibri"/>
-            </a:endParaRPr>
-          </a:p>
-        </p:txBody>
-      </p:sp>
-      <p:sp>
-        <p:nvSpPr>
-          <p:cNvPr id="229" name="Google Shape;229;p20"/>
-          <p:cNvSpPr/>
-          <p:nvPr/>
-        </p:nvSpPr>
-        <p:spPr>
-          <a:xfrm>
-            <a:off x="3210371" y="3633787"/>
-            <a:ext cx="1458813" cy="9525"/>
-          </a:xfrm>
-          <a:prstGeom prst="rect">
-            <a:avLst/>
-          </a:prstGeom>
-          <a:solidFill>
-            <a:srgbClr val="E6E9E6"/>
-          </a:solidFill>
-          <a:ln>
-            <a:noFill/>
-          </a:ln>
-        </p:spPr>
-        <p:txBody>
-          <a:bodyPr anchorCtr="0" anchor="ctr" bIns="45700" lIns="91425" spcFirstLastPara="1" rIns="91425" wrap="square" tIns="45700">
-            <a:noAutofit/>
-          </a:bodyPr>
-          <a:lstStyle/>
-          <a:p>
-            <a:pPr indent="0" lvl="0" marL="0" marR="0" rtl="0" algn="ctr">
-              <a:spcBef>
-                <a:spcPts val="0"/>
-              </a:spcBef>
-              <a:spcAft>
-                <a:spcPts val="0"/>
-              </a:spcAft>
-              <a:buNone/>
-            </a:pPr>
-            <a:r>
-              <a:t/>
-            </a:r>
-            <a:endParaRPr b="0" i="0" sz="1800" u="none" cap="none" strike="noStrike">
-              <a:solidFill>
-                <a:schemeClr val="dk1"/>
-              </a:solidFill>
-              <a:latin typeface="Calibri"/>
-              <a:ea typeface="Calibri"/>
-              <a:cs typeface="Calibri"/>
-              <a:sym typeface="Calibri"/>
-            </a:endParaRPr>
-          </a:p>
-        </p:txBody>
-      </p:sp>
-      <p:sp>
-        <p:nvSpPr>
-          <p:cNvPr id="230" name="Google Shape;230;p20"/>
-          <p:cNvSpPr/>
-          <p:nvPr/>
-        </p:nvSpPr>
-        <p:spPr>
-          <a:xfrm>
-            <a:off x="4669184" y="3633787"/>
-            <a:ext cx="1372939" cy="9525"/>
-          </a:xfrm>
-          <a:prstGeom prst="rect">
-            <a:avLst/>
-          </a:prstGeom>
-          <a:solidFill>
-            <a:srgbClr val="E6E9E6"/>
-          </a:solidFill>
-          <a:ln>
-            <a:noFill/>
-          </a:ln>
-        </p:spPr>
-        <p:txBody>
-          <a:bodyPr anchorCtr="0" anchor="ctr" bIns="45700" lIns="91425" spcFirstLastPara="1" rIns="91425" wrap="square" tIns="45700">
-            <a:noAutofit/>
-          </a:bodyPr>
-          <a:lstStyle/>
-          <a:p>
-            <a:pPr indent="0" lvl="0" marL="0" marR="0" rtl="0" algn="ctr">
-              <a:spcBef>
-                <a:spcPts val="0"/>
-              </a:spcBef>
-              <a:spcAft>
-                <a:spcPts val="0"/>
-              </a:spcAft>
-              <a:buNone/>
-            </a:pPr>
-            <a:r>
-              <a:t/>
-            </a:r>
-            <a:endParaRPr b="0" i="0" sz="1800" u="none" cap="none" strike="noStrike">
-              <a:solidFill>
-                <a:schemeClr val="dk1"/>
-              </a:solidFill>
-              <a:latin typeface="Calibri"/>
-              <a:ea typeface="Calibri"/>
-              <a:cs typeface="Calibri"/>
-              <a:sym typeface="Calibri"/>
-            </a:endParaRPr>
-          </a:p>
-        </p:txBody>
-      </p:sp>
-      <p:sp>
-        <p:nvSpPr>
-          <p:cNvPr id="231" name="Google Shape;231;p20"/>
-          <p:cNvSpPr/>
-          <p:nvPr/>
-        </p:nvSpPr>
-        <p:spPr>
-          <a:xfrm>
-            <a:off x="6042124" y="3633787"/>
-            <a:ext cx="1952327" cy="9525"/>
-          </a:xfrm>
-          <a:prstGeom prst="rect">
-            <a:avLst/>
-          </a:prstGeom>
-          <a:solidFill>
-            <a:srgbClr val="E6E9E6"/>
-          </a:solidFill>
-          <a:ln>
-            <a:noFill/>
-          </a:ln>
-        </p:spPr>
-        <p:txBody>
-          <a:bodyPr anchorCtr="0" anchor="ctr" bIns="45700" lIns="91425" spcFirstLastPara="1" rIns="91425" wrap="square" tIns="45700">
-            <a:noAutofit/>
-          </a:bodyPr>
-          <a:lstStyle/>
-          <a:p>
-            <a:pPr indent="0" lvl="0" marL="0" marR="0" rtl="0" algn="ctr">
-              <a:spcBef>
-                <a:spcPts val="0"/>
-              </a:spcBef>
-              <a:spcAft>
-                <a:spcPts val="0"/>
-              </a:spcAft>
-              <a:buNone/>
-            </a:pPr>
-            <a:r>
-              <a:t/>
-            </a:r>
-            <a:endParaRPr b="0" i="0" sz="1800" u="none" cap="none" strike="noStrike">
-              <a:solidFill>
-                <a:schemeClr val="dk1"/>
-              </a:solidFill>
-              <a:latin typeface="Calibri"/>
-              <a:ea typeface="Calibri"/>
-              <a:cs typeface="Calibri"/>
-              <a:sym typeface="Calibri"/>
-            </a:endParaRPr>
-          </a:p>
-        </p:txBody>
-      </p:sp>
-      <p:sp>
-        <p:nvSpPr>
-          <p:cNvPr id="232" name="Google Shape;232;p20"/>
-          <p:cNvSpPr/>
-          <p:nvPr/>
-        </p:nvSpPr>
-        <p:spPr>
-          <a:xfrm>
-            <a:off x="7994451" y="3633787"/>
-            <a:ext cx="1877169" cy="9525"/>
-          </a:xfrm>
-          <a:prstGeom prst="rect">
-            <a:avLst/>
-          </a:prstGeom>
-          <a:solidFill>
-            <a:srgbClr val="E6E9E6"/>
-          </a:solidFill>
-          <a:ln>
-            <a:noFill/>
-          </a:ln>
-        </p:spPr>
-        <p:txBody>
-          <a:bodyPr anchorCtr="0" anchor="ctr" bIns="45700" lIns="91425" spcFirstLastPara="1" rIns="91425" wrap="square" tIns="45700">
-            <a:noAutofit/>
-          </a:bodyPr>
-          <a:lstStyle/>
-          <a:p>
-            <a:pPr indent="0" lvl="0" marL="0" marR="0" rtl="0" algn="ctr">
-              <a:spcBef>
-                <a:spcPts val="0"/>
-              </a:spcBef>
-              <a:spcAft>
-                <a:spcPts val="0"/>
-              </a:spcAft>
-              <a:buNone/>
-            </a:pPr>
-            <a:r>
-              <a:t/>
-            </a:r>
-            <a:endParaRPr b="0" i="0" sz="1800" u="none" cap="none" strike="noStrike">
-              <a:solidFill>
-                <a:schemeClr val="dk1"/>
-              </a:solidFill>
-              <a:latin typeface="Calibri"/>
-              <a:ea typeface="Calibri"/>
-              <a:cs typeface="Calibri"/>
-              <a:sym typeface="Calibri"/>
-            </a:endParaRPr>
-          </a:p>
-        </p:txBody>
-      </p:sp>
-      <p:sp>
-        <p:nvSpPr>
-          <p:cNvPr id="233" name="Google Shape;233;p20"/>
-          <p:cNvSpPr/>
-          <p:nvPr/>
-        </p:nvSpPr>
-        <p:spPr>
-          <a:xfrm>
-            <a:off x="9871620" y="3633787"/>
-            <a:ext cx="1748879" cy="9525"/>
-          </a:xfrm>
-          <a:prstGeom prst="rect">
-            <a:avLst/>
-          </a:prstGeom>
-          <a:solidFill>
-            <a:srgbClr val="E6E9E6"/>
-          </a:solidFill>
-          <a:ln>
-            <a:noFill/>
-          </a:ln>
-        </p:spPr>
-        <p:txBody>
-          <a:bodyPr anchorCtr="0" anchor="ctr" bIns="45700" lIns="91425" spcFirstLastPara="1" rIns="91425" wrap="square" tIns="45700">
-            <a:noAutofit/>
-          </a:bodyPr>
-          <a:lstStyle/>
-          <a:p>
-            <a:pPr indent="0" lvl="0" marL="0" marR="0" rtl="0" algn="ctr">
-              <a:spcBef>
-                <a:spcPts val="0"/>
-              </a:spcBef>
-              <a:spcAft>
-                <a:spcPts val="0"/>
-              </a:spcAft>
-              <a:buNone/>
-            </a:pPr>
-            <a:r>
-              <a:t/>
-            </a:r>
-            <a:endParaRPr b="0" i="0" sz="1800" u="none" cap="none" strike="noStrike">
-              <a:solidFill>
-                <a:schemeClr val="dk1"/>
-              </a:solidFill>
-              <a:latin typeface="Calibri"/>
-              <a:ea typeface="Calibri"/>
-              <a:cs typeface="Calibri"/>
-              <a:sym typeface="Calibri"/>
-            </a:endParaRPr>
-          </a:p>
-        </p:txBody>
-      </p:sp>
-      <p:sp>
-        <p:nvSpPr>
-          <p:cNvPr id="234" name="Google Shape;234;p20"/>
-          <p:cNvSpPr/>
-          <p:nvPr/>
-        </p:nvSpPr>
-        <p:spPr>
-          <a:xfrm>
-            <a:off x="571500" y="4024312"/>
-            <a:ext cx="2638871" cy="9525"/>
-          </a:xfrm>
-          <a:prstGeom prst="rect">
-            <a:avLst/>
-          </a:prstGeom>
-          <a:solidFill>
-            <a:srgbClr val="E6E9E6"/>
-          </a:solidFill>
-          <a:ln>
-            <a:noFill/>
-          </a:ln>
-        </p:spPr>
-        <p:txBody>
-          <a:bodyPr anchorCtr="0" anchor="ctr" bIns="45700" lIns="91425" spcFirstLastPara="1" rIns="91425" wrap="square" tIns="45700">
-            <a:noAutofit/>
-          </a:bodyPr>
-          <a:lstStyle/>
-          <a:p>
-            <a:pPr indent="0" lvl="0" marL="0" marR="0" rtl="0" algn="ctr">
-              <a:spcBef>
-                <a:spcPts val="0"/>
-              </a:spcBef>
-              <a:spcAft>
-                <a:spcPts val="0"/>
-              </a:spcAft>
-              <a:buNone/>
-            </a:pPr>
-            <a:r>
-              <a:t/>
-            </a:r>
-            <a:endParaRPr b="0" i="0" sz="1800" u="none" cap="none" strike="noStrike">
-              <a:solidFill>
-                <a:schemeClr val="dk1"/>
-              </a:solidFill>
-              <a:latin typeface="Calibri"/>
-              <a:ea typeface="Calibri"/>
-              <a:cs typeface="Calibri"/>
-              <a:sym typeface="Calibri"/>
-            </a:endParaRPr>
-          </a:p>
-        </p:txBody>
-      </p:sp>
-      <p:sp>
-        <p:nvSpPr>
-          <p:cNvPr id="235" name="Google Shape;235;p20"/>
-          <p:cNvSpPr/>
-          <p:nvPr/>
-        </p:nvSpPr>
-        <p:spPr>
-          <a:xfrm>
-            <a:off x="3210371" y="4024312"/>
-            <a:ext cx="1458813" cy="9525"/>
-          </a:xfrm>
-          <a:prstGeom prst="rect">
-            <a:avLst/>
-          </a:prstGeom>
-          <a:solidFill>
-            <a:srgbClr val="E6E9E6"/>
-          </a:solidFill>
-          <a:ln>
-            <a:noFill/>
-          </a:ln>
-        </p:spPr>
-        <p:txBody>
-          <a:bodyPr anchorCtr="0" anchor="ctr" bIns="45700" lIns="91425" spcFirstLastPara="1" rIns="91425" wrap="square" tIns="45700">
-            <a:noAutofit/>
-          </a:bodyPr>
-          <a:lstStyle/>
-          <a:p>
-            <a:pPr indent="0" lvl="0" marL="0" marR="0" rtl="0" algn="ctr">
-              <a:spcBef>
-                <a:spcPts val="0"/>
-              </a:spcBef>
-              <a:spcAft>
-                <a:spcPts val="0"/>
-              </a:spcAft>
-              <a:buNone/>
-            </a:pPr>
-            <a:r>
-              <a:t/>
-            </a:r>
-            <a:endParaRPr b="0" i="0" sz="1800" u="none" cap="none" strike="noStrike">
-              <a:solidFill>
-                <a:schemeClr val="dk1"/>
-              </a:solidFill>
-              <a:latin typeface="Calibri"/>
-              <a:ea typeface="Calibri"/>
-              <a:cs typeface="Calibri"/>
-              <a:sym typeface="Calibri"/>
-            </a:endParaRPr>
-          </a:p>
-        </p:txBody>
-      </p:sp>
-      <p:sp>
-        <p:nvSpPr>
-          <p:cNvPr id="236" name="Google Shape;236;p20"/>
-          <p:cNvSpPr/>
-          <p:nvPr/>
-        </p:nvSpPr>
-        <p:spPr>
-          <a:xfrm>
-            <a:off x="4669184" y="4024312"/>
-            <a:ext cx="1372939" cy="9525"/>
-          </a:xfrm>
-          <a:prstGeom prst="rect">
-            <a:avLst/>
-          </a:prstGeom>
-          <a:solidFill>
-            <a:srgbClr val="E6E9E6"/>
-          </a:solidFill>
-          <a:ln>
-            <a:noFill/>
-          </a:ln>
-        </p:spPr>
-        <p:txBody>
-          <a:bodyPr anchorCtr="0" anchor="ctr" bIns="45700" lIns="91425" spcFirstLastPara="1" rIns="91425" wrap="square" tIns="45700">
-            <a:noAutofit/>
-          </a:bodyPr>
-          <a:lstStyle/>
-          <a:p>
-            <a:pPr indent="0" lvl="0" marL="0" marR="0" rtl="0" algn="ctr">
-              <a:spcBef>
-                <a:spcPts val="0"/>
-              </a:spcBef>
-              <a:spcAft>
-                <a:spcPts val="0"/>
-              </a:spcAft>
-              <a:buNone/>
-            </a:pPr>
-            <a:r>
-              <a:t/>
-            </a:r>
-            <a:endParaRPr b="0" i="0" sz="1800" u="none" cap="none" strike="noStrike">
-              <a:solidFill>
-                <a:schemeClr val="dk1"/>
-              </a:solidFill>
-              <a:latin typeface="Calibri"/>
-              <a:ea typeface="Calibri"/>
-              <a:cs typeface="Calibri"/>
-              <a:sym typeface="Calibri"/>
-            </a:endParaRPr>
-          </a:p>
-        </p:txBody>
-      </p:sp>
-      <p:sp>
-        <p:nvSpPr>
-          <p:cNvPr id="237" name="Google Shape;237;p20"/>
-          <p:cNvSpPr/>
-          <p:nvPr/>
-        </p:nvSpPr>
-        <p:spPr>
-          <a:xfrm>
-            <a:off x="6042124" y="4024312"/>
-            <a:ext cx="1952327" cy="9525"/>
-          </a:xfrm>
-          <a:prstGeom prst="rect">
-            <a:avLst/>
-          </a:prstGeom>
-          <a:solidFill>
-            <a:srgbClr val="E6E9E6"/>
-          </a:solidFill>
-          <a:ln>
-            <a:noFill/>
-          </a:ln>
-        </p:spPr>
-        <p:txBody>
-          <a:bodyPr anchorCtr="0" anchor="ctr" bIns="45700" lIns="91425" spcFirstLastPara="1" rIns="91425" wrap="square" tIns="45700">
-            <a:noAutofit/>
-          </a:bodyPr>
-          <a:lstStyle/>
-          <a:p>
-            <a:pPr indent="0" lvl="0" marL="0" marR="0" rtl="0" algn="ctr">
-              <a:spcBef>
-                <a:spcPts val="0"/>
-              </a:spcBef>
-              <a:spcAft>
-                <a:spcPts val="0"/>
-              </a:spcAft>
-              <a:buNone/>
-            </a:pPr>
-            <a:r>
-              <a:t/>
-            </a:r>
-            <a:endParaRPr b="0" i="0" sz="1800" u="none" cap="none" strike="noStrike">
-              <a:solidFill>
-                <a:schemeClr val="dk1"/>
-              </a:solidFill>
-              <a:latin typeface="Calibri"/>
-              <a:ea typeface="Calibri"/>
-              <a:cs typeface="Calibri"/>
-              <a:sym typeface="Calibri"/>
-            </a:endParaRPr>
-          </a:p>
-        </p:txBody>
-      </p:sp>
-      <p:sp>
-        <p:nvSpPr>
-          <p:cNvPr id="238" name="Google Shape;238;p20"/>
-          <p:cNvSpPr/>
-          <p:nvPr/>
-        </p:nvSpPr>
-        <p:spPr>
-          <a:xfrm>
-            <a:off x="7994451" y="4024312"/>
-            <a:ext cx="1877169" cy="9525"/>
-          </a:xfrm>
-          <a:prstGeom prst="rect">
-            <a:avLst/>
-          </a:prstGeom>
-          <a:solidFill>
-            <a:srgbClr val="E6E9E6"/>
-          </a:solidFill>
-          <a:ln>
-            <a:noFill/>
-          </a:ln>
-        </p:spPr>
-        <p:txBody>
-          <a:bodyPr anchorCtr="0" anchor="ctr" bIns="45700" lIns="91425" spcFirstLastPara="1" rIns="91425" wrap="square" tIns="45700">
-            <a:noAutofit/>
-          </a:bodyPr>
-          <a:lstStyle/>
-          <a:p>
-            <a:pPr indent="0" lvl="0" marL="0" marR="0" rtl="0" algn="ctr">
-              <a:spcBef>
-                <a:spcPts val="0"/>
-              </a:spcBef>
-              <a:spcAft>
-                <a:spcPts val="0"/>
-              </a:spcAft>
-              <a:buNone/>
-            </a:pPr>
-            <a:r>
-              <a:t/>
-            </a:r>
-            <a:endParaRPr b="0" i="0" sz="1800" u="none" cap="none" strike="noStrike">
-              <a:solidFill>
-                <a:schemeClr val="dk1"/>
-              </a:solidFill>
-              <a:latin typeface="Calibri"/>
-              <a:ea typeface="Calibri"/>
-              <a:cs typeface="Calibri"/>
-              <a:sym typeface="Calibri"/>
-            </a:endParaRPr>
-          </a:p>
-        </p:txBody>
-      </p:sp>
-      <p:sp>
-        <p:nvSpPr>
-          <p:cNvPr id="239" name="Google Shape;239;p20"/>
-          <p:cNvSpPr/>
-          <p:nvPr/>
-        </p:nvSpPr>
-        <p:spPr>
-          <a:xfrm>
-            <a:off x="9871620" y="4024312"/>
-            <a:ext cx="1748879" cy="9525"/>
-          </a:xfrm>
-          <a:prstGeom prst="rect">
-            <a:avLst/>
-          </a:prstGeom>
-          <a:solidFill>
-            <a:srgbClr val="E6E9E6"/>
-          </a:solidFill>
-          <a:ln>
-            <a:noFill/>
-          </a:ln>
-        </p:spPr>
-        <p:txBody>
-          <a:bodyPr anchorCtr="0" anchor="ctr" bIns="45700" lIns="91425" spcFirstLastPara="1" rIns="91425" wrap="square" tIns="45700">
-            <a:noAutofit/>
-          </a:bodyPr>
-          <a:lstStyle/>
-          <a:p>
-            <a:pPr indent="0" lvl="0" marL="0" marR="0" rtl="0" algn="ctr">
-              <a:spcBef>
-                <a:spcPts val="0"/>
-              </a:spcBef>
-              <a:spcAft>
-                <a:spcPts val="0"/>
-              </a:spcAft>
-              <a:buNone/>
-            </a:pPr>
-            <a:r>
-              <a:t/>
-            </a:r>
-            <a:endParaRPr b="0" i="0" sz="1800" u="none" cap="none" strike="noStrike">
-              <a:solidFill>
-                <a:schemeClr val="dk1"/>
-              </a:solidFill>
-              <a:latin typeface="Calibri"/>
-              <a:ea typeface="Calibri"/>
-              <a:cs typeface="Calibri"/>
-              <a:sym typeface="Calibri"/>
-            </a:endParaRPr>
-          </a:p>
-        </p:txBody>
-      </p:sp>
-      <p:sp>
-        <p:nvSpPr>
-          <p:cNvPr id="240" name="Google Shape;240;p20"/>
-          <p:cNvSpPr/>
-          <p:nvPr/>
-        </p:nvSpPr>
-        <p:spPr>
-          <a:xfrm>
-            <a:off x="571500" y="4414837"/>
-            <a:ext cx="2638871" cy="9525"/>
-          </a:xfrm>
-          <a:prstGeom prst="rect">
-            <a:avLst/>
-          </a:prstGeom>
-          <a:solidFill>
-            <a:srgbClr val="E6E9E6"/>
-          </a:solidFill>
-          <a:ln>
-            <a:noFill/>
-          </a:ln>
-        </p:spPr>
-        <p:txBody>
-          <a:bodyPr anchorCtr="0" anchor="ctr" bIns="45700" lIns="91425" spcFirstLastPara="1" rIns="91425" wrap="square" tIns="45700">
-            <a:noAutofit/>
-          </a:bodyPr>
-          <a:lstStyle/>
-          <a:p>
-            <a:pPr indent="0" lvl="0" marL="0" marR="0" rtl="0" algn="ctr">
-              <a:spcBef>
-                <a:spcPts val="0"/>
-              </a:spcBef>
-              <a:spcAft>
-                <a:spcPts val="0"/>
-              </a:spcAft>
-              <a:buNone/>
-            </a:pPr>
-            <a:r>
-              <a:t/>
-            </a:r>
-            <a:endParaRPr b="0" i="0" sz="1800" u="none" cap="none" strike="noStrike">
-              <a:solidFill>
-                <a:schemeClr val="dk1"/>
-              </a:solidFill>
-              <a:latin typeface="Calibri"/>
-              <a:ea typeface="Calibri"/>
-              <a:cs typeface="Calibri"/>
-              <a:sym typeface="Calibri"/>
-            </a:endParaRPr>
-          </a:p>
-        </p:txBody>
-      </p:sp>
-      <p:sp>
-        <p:nvSpPr>
-          <p:cNvPr id="241" name="Google Shape;241;p20"/>
-          <p:cNvSpPr/>
-          <p:nvPr/>
-        </p:nvSpPr>
-        <p:spPr>
-          <a:xfrm>
-            <a:off x="3210371" y="4414837"/>
-            <a:ext cx="1458813" cy="9525"/>
-          </a:xfrm>
-          <a:prstGeom prst="rect">
-            <a:avLst/>
-          </a:prstGeom>
-          <a:solidFill>
-            <a:srgbClr val="E6E9E6"/>
-          </a:solidFill>
-          <a:ln>
-            <a:noFill/>
-          </a:ln>
-        </p:spPr>
-        <p:txBody>
-          <a:bodyPr anchorCtr="0" anchor="ctr" bIns="45700" lIns="91425" spcFirstLastPara="1" rIns="91425" wrap="square" tIns="45700">
-            <a:noAutofit/>
-          </a:bodyPr>
-          <a:lstStyle/>
-          <a:p>
-            <a:pPr indent="0" lvl="0" marL="0" marR="0" rtl="0" algn="ctr">
-              <a:spcBef>
-                <a:spcPts val="0"/>
-              </a:spcBef>
-              <a:spcAft>
-                <a:spcPts val="0"/>
-              </a:spcAft>
-              <a:buNone/>
-            </a:pPr>
-            <a:r>
-              <a:t/>
-            </a:r>
-            <a:endParaRPr b="0" i="0" sz="1800" u="none" cap="none" strike="noStrike">
-              <a:solidFill>
-                <a:schemeClr val="dk1"/>
-              </a:solidFill>
-              <a:latin typeface="Calibri"/>
-              <a:ea typeface="Calibri"/>
-              <a:cs typeface="Calibri"/>
-              <a:sym typeface="Calibri"/>
-            </a:endParaRPr>
-          </a:p>
-        </p:txBody>
-      </p:sp>
-      <p:sp>
-        <p:nvSpPr>
-          <p:cNvPr id="242" name="Google Shape;242;p20"/>
-          <p:cNvSpPr/>
-          <p:nvPr/>
-        </p:nvSpPr>
-        <p:spPr>
-          <a:xfrm>
-            <a:off x="4669184" y="4414837"/>
-            <a:ext cx="1372939" cy="9525"/>
-          </a:xfrm>
-          <a:prstGeom prst="rect">
-            <a:avLst/>
-          </a:prstGeom>
-          <a:solidFill>
-            <a:srgbClr val="E6E9E6"/>
-          </a:solidFill>
-          <a:ln>
-            <a:noFill/>
-          </a:ln>
-        </p:spPr>
-        <p:txBody>
-          <a:bodyPr anchorCtr="0" anchor="ctr" bIns="45700" lIns="91425" spcFirstLastPara="1" rIns="91425" wrap="square" tIns="45700">
-            <a:noAutofit/>
-          </a:bodyPr>
-          <a:lstStyle/>
-          <a:p>
-            <a:pPr indent="0" lvl="0" marL="0" marR="0" rtl="0" algn="ctr">
-              <a:spcBef>
-                <a:spcPts val="0"/>
-              </a:spcBef>
-              <a:spcAft>
-                <a:spcPts val="0"/>
-              </a:spcAft>
-              <a:buNone/>
-            </a:pPr>
-            <a:r>
-              <a:t/>
-            </a:r>
-            <a:endParaRPr b="0" i="0" sz="1800" u="none" cap="none" strike="noStrike">
-              <a:solidFill>
-                <a:schemeClr val="dk1"/>
-              </a:solidFill>
-              <a:latin typeface="Calibri"/>
-              <a:ea typeface="Calibri"/>
-              <a:cs typeface="Calibri"/>
-              <a:sym typeface="Calibri"/>
-            </a:endParaRPr>
-          </a:p>
-        </p:txBody>
-      </p:sp>
-      <p:sp>
-        <p:nvSpPr>
-          <p:cNvPr id="243" name="Google Shape;243;p20"/>
-          <p:cNvSpPr/>
-          <p:nvPr/>
-        </p:nvSpPr>
-        <p:spPr>
-          <a:xfrm>
-            <a:off x="6042124" y="4414837"/>
-            <a:ext cx="1952327" cy="9525"/>
-          </a:xfrm>
-          <a:prstGeom prst="rect">
-            <a:avLst/>
-          </a:prstGeom>
-          <a:solidFill>
-            <a:srgbClr val="E6E9E6"/>
-          </a:solidFill>
-          <a:ln>
-            <a:noFill/>
-          </a:ln>
-        </p:spPr>
-        <p:txBody>
-          <a:bodyPr anchorCtr="0" anchor="ctr" bIns="45700" lIns="91425" spcFirstLastPara="1" rIns="91425" wrap="square" tIns="45700">
-            <a:noAutofit/>
-          </a:bodyPr>
-          <a:lstStyle/>
-          <a:p>
-            <a:pPr indent="0" lvl="0" marL="0" marR="0" rtl="0" algn="ctr">
-              <a:spcBef>
-                <a:spcPts val="0"/>
-              </a:spcBef>
-              <a:spcAft>
-                <a:spcPts val="0"/>
-              </a:spcAft>
-              <a:buNone/>
-            </a:pPr>
-            <a:r>
-              <a:t/>
-            </a:r>
-            <a:endParaRPr b="0" i="0" sz="1800" u="none" cap="none" strike="noStrike">
-              <a:solidFill>
-                <a:schemeClr val="dk1"/>
-              </a:solidFill>
-              <a:latin typeface="Calibri"/>
-              <a:ea typeface="Calibri"/>
-              <a:cs typeface="Calibri"/>
-              <a:sym typeface="Calibri"/>
-            </a:endParaRPr>
-          </a:p>
-        </p:txBody>
-      </p:sp>
-      <p:sp>
-        <p:nvSpPr>
-          <p:cNvPr id="244" name="Google Shape;244;p20"/>
-          <p:cNvSpPr/>
-          <p:nvPr/>
-        </p:nvSpPr>
-        <p:spPr>
-          <a:xfrm>
-            <a:off x="7994451" y="4414837"/>
-            <a:ext cx="1877169" cy="9525"/>
-          </a:xfrm>
-          <a:prstGeom prst="rect">
-            <a:avLst/>
-          </a:prstGeom>
-          <a:solidFill>
-            <a:srgbClr val="E6E9E6"/>
-          </a:solidFill>
-          <a:ln>
-            <a:noFill/>
-          </a:ln>
-        </p:spPr>
-        <p:txBody>
-          <a:bodyPr anchorCtr="0" anchor="ctr" bIns="45700" lIns="91425" spcFirstLastPara="1" rIns="91425" wrap="square" tIns="45700">
-            <a:noAutofit/>
-          </a:bodyPr>
-          <a:lstStyle/>
-          <a:p>
-            <a:pPr indent="0" lvl="0" marL="0" marR="0" rtl="0" algn="ctr">
-              <a:spcBef>
-                <a:spcPts val="0"/>
-              </a:spcBef>
-              <a:spcAft>
-                <a:spcPts val="0"/>
-              </a:spcAft>
-              <a:buNone/>
-            </a:pPr>
-            <a:r>
-              <a:t/>
-            </a:r>
-            <a:endParaRPr b="0" i="0" sz="1800" u="none" cap="none" strike="noStrike">
-              <a:solidFill>
-                <a:schemeClr val="dk1"/>
-              </a:solidFill>
-              <a:latin typeface="Calibri"/>
-              <a:ea typeface="Calibri"/>
-              <a:cs typeface="Calibri"/>
-              <a:sym typeface="Calibri"/>
-            </a:endParaRPr>
-          </a:p>
-        </p:txBody>
-      </p:sp>
-      <p:sp>
-        <p:nvSpPr>
-          <p:cNvPr id="245" name="Google Shape;245;p20"/>
-          <p:cNvSpPr/>
-          <p:nvPr/>
-        </p:nvSpPr>
-        <p:spPr>
-          <a:xfrm>
-            <a:off x="9871620" y="4414837"/>
-            <a:ext cx="1748879" cy="9525"/>
-          </a:xfrm>
-          <a:prstGeom prst="rect">
-            <a:avLst/>
-          </a:prstGeom>
-          <a:solidFill>
-            <a:srgbClr val="E6E9E6"/>
-          </a:solidFill>
-          <a:ln>
-            <a:noFill/>
-          </a:ln>
-        </p:spPr>
-        <p:txBody>
-          <a:bodyPr anchorCtr="0" anchor="ctr" bIns="45700" lIns="91425" spcFirstLastPara="1" rIns="91425" wrap="square" tIns="45700">
-            <a:noAutofit/>
-          </a:bodyPr>
-          <a:lstStyle/>
-          <a:p>
-            <a:pPr indent="0" lvl="0" marL="0" marR="0" rtl="0" algn="ctr">
-              <a:spcBef>
-                <a:spcPts val="0"/>
-              </a:spcBef>
-              <a:spcAft>
-                <a:spcPts val="0"/>
-              </a:spcAft>
-              <a:buNone/>
-            </a:pPr>
-            <a:r>
-              <a:t/>
-            </a:r>
-            <a:endParaRPr b="0" i="0" sz="1800" u="none" cap="none" strike="noStrike">
-              <a:solidFill>
-                <a:schemeClr val="dk1"/>
-              </a:solidFill>
-              <a:latin typeface="Calibri"/>
-              <a:ea typeface="Calibri"/>
-              <a:cs typeface="Calibri"/>
-              <a:sym typeface="Calibri"/>
-            </a:endParaRPr>
-          </a:p>
-        </p:txBody>
-      </p:sp>
-      <p:sp>
-        <p:nvSpPr>
-          <p:cNvPr id="246" name="Google Shape;246;p20"/>
-          <p:cNvSpPr/>
-          <p:nvPr/>
-        </p:nvSpPr>
-        <p:spPr>
-          <a:xfrm>
-            <a:off x="571500" y="4805362"/>
-            <a:ext cx="2638871" cy="9525"/>
-          </a:xfrm>
-          <a:prstGeom prst="rect">
-            <a:avLst/>
-          </a:prstGeom>
-          <a:solidFill>
-            <a:srgbClr val="E6E9E6"/>
-          </a:solidFill>
-          <a:ln>
-            <a:noFill/>
-          </a:ln>
-        </p:spPr>
-        <p:txBody>
-          <a:bodyPr anchorCtr="0" anchor="ctr" bIns="45700" lIns="91425" spcFirstLastPara="1" rIns="91425" wrap="square" tIns="45700">
-            <a:noAutofit/>
-          </a:bodyPr>
-          <a:lstStyle/>
-          <a:p>
-            <a:pPr indent="0" lvl="0" marL="0" marR="0" rtl="0" algn="ctr">
-              <a:spcBef>
-                <a:spcPts val="0"/>
-              </a:spcBef>
-              <a:spcAft>
-                <a:spcPts val="0"/>
-              </a:spcAft>
-              <a:buNone/>
-            </a:pPr>
-            <a:r>
-              <a:t/>
-            </a:r>
-            <a:endParaRPr b="0" i="0" sz="1800" u="none" cap="none" strike="noStrike">
-              <a:solidFill>
-                <a:schemeClr val="dk1"/>
-              </a:solidFill>
-              <a:latin typeface="Calibri"/>
-              <a:ea typeface="Calibri"/>
-              <a:cs typeface="Calibri"/>
-              <a:sym typeface="Calibri"/>
-            </a:endParaRPr>
-          </a:p>
-        </p:txBody>
-      </p:sp>
-      <p:sp>
-        <p:nvSpPr>
-          <p:cNvPr id="247" name="Google Shape;247;p20"/>
-          <p:cNvSpPr/>
-          <p:nvPr/>
-        </p:nvSpPr>
-        <p:spPr>
-          <a:xfrm>
-            <a:off x="3210371" y="4805362"/>
-            <a:ext cx="1458813" cy="9525"/>
-          </a:xfrm>
-          <a:prstGeom prst="rect">
-            <a:avLst/>
-          </a:prstGeom>
-          <a:solidFill>
-            <a:srgbClr val="E6E9E6"/>
-          </a:solidFill>
-          <a:ln>
-            <a:noFill/>
-          </a:ln>
-        </p:spPr>
-        <p:txBody>
-          <a:bodyPr anchorCtr="0" anchor="ctr" bIns="45700" lIns="91425" spcFirstLastPara="1" rIns="91425" wrap="square" tIns="45700">
-            <a:noAutofit/>
-          </a:bodyPr>
-          <a:lstStyle/>
-          <a:p>
-            <a:pPr indent="0" lvl="0" marL="0" marR="0" rtl="0" algn="ctr">
-              <a:spcBef>
-                <a:spcPts val="0"/>
-              </a:spcBef>
-              <a:spcAft>
-                <a:spcPts val="0"/>
-              </a:spcAft>
-              <a:buNone/>
-            </a:pPr>
-            <a:r>
-              <a:t/>
-            </a:r>
-            <a:endParaRPr b="0" i="0" sz="1800" u="none" cap="none" strike="noStrike">
-              <a:solidFill>
-                <a:schemeClr val="dk1"/>
-              </a:solidFill>
-              <a:latin typeface="Calibri"/>
-              <a:ea typeface="Calibri"/>
-              <a:cs typeface="Calibri"/>
-              <a:sym typeface="Calibri"/>
-            </a:endParaRPr>
-          </a:p>
-        </p:txBody>
-      </p:sp>
-      <p:sp>
-        <p:nvSpPr>
-          <p:cNvPr id="248" name="Google Shape;248;p20"/>
-          <p:cNvSpPr/>
-          <p:nvPr/>
-        </p:nvSpPr>
-        <p:spPr>
-          <a:xfrm>
-            <a:off x="4669184" y="4805362"/>
-            <a:ext cx="1372939" cy="9525"/>
-          </a:xfrm>
-          <a:prstGeom prst="rect">
-            <a:avLst/>
-          </a:prstGeom>
-          <a:solidFill>
-            <a:srgbClr val="E6E9E6"/>
-          </a:solidFill>
-          <a:ln>
-            <a:noFill/>
-          </a:ln>
-        </p:spPr>
-        <p:txBody>
-          <a:bodyPr anchorCtr="0" anchor="ctr" bIns="45700" lIns="91425" spcFirstLastPara="1" rIns="91425" wrap="square" tIns="45700">
-            <a:noAutofit/>
-          </a:bodyPr>
-          <a:lstStyle/>
-          <a:p>
-            <a:pPr indent="0" lvl="0" marL="0" marR="0" rtl="0" algn="ctr">
-              <a:spcBef>
-                <a:spcPts val="0"/>
-              </a:spcBef>
-              <a:spcAft>
-                <a:spcPts val="0"/>
-              </a:spcAft>
-              <a:buNone/>
-            </a:pPr>
-            <a:r>
-              <a:t/>
-            </a:r>
-            <a:endParaRPr b="0" i="0" sz="1800" u="none" cap="none" strike="noStrike">
-              <a:solidFill>
-                <a:schemeClr val="dk1"/>
-              </a:solidFill>
-              <a:latin typeface="Calibri"/>
-              <a:ea typeface="Calibri"/>
-              <a:cs typeface="Calibri"/>
-              <a:sym typeface="Calibri"/>
-            </a:endParaRPr>
-          </a:p>
-        </p:txBody>
-      </p:sp>
-      <p:sp>
-        <p:nvSpPr>
-          <p:cNvPr id="249" name="Google Shape;249;p20"/>
-          <p:cNvSpPr/>
-          <p:nvPr/>
-        </p:nvSpPr>
-        <p:spPr>
-          <a:xfrm>
-            <a:off x="6042124" y="4805362"/>
-            <a:ext cx="1952327" cy="9525"/>
-          </a:xfrm>
-          <a:prstGeom prst="rect">
-            <a:avLst/>
-          </a:prstGeom>
-          <a:solidFill>
-            <a:srgbClr val="E6E9E6"/>
-          </a:solidFill>
-          <a:ln>
-            <a:noFill/>
-          </a:ln>
-        </p:spPr>
-        <p:txBody>
-          <a:bodyPr anchorCtr="0" anchor="ctr" bIns="45700" lIns="91425" spcFirstLastPara="1" rIns="91425" wrap="square" tIns="45700">
-            <a:noAutofit/>
-          </a:bodyPr>
-          <a:lstStyle/>
-          <a:p>
-            <a:pPr indent="0" lvl="0" marL="0" marR="0" rtl="0" algn="ctr">
-              <a:spcBef>
-                <a:spcPts val="0"/>
-              </a:spcBef>
-              <a:spcAft>
-                <a:spcPts val="0"/>
-              </a:spcAft>
-              <a:buNone/>
-            </a:pPr>
-            <a:r>
-              <a:t/>
-            </a:r>
-            <a:endParaRPr b="0" i="0" sz="1800" u="none" cap="none" strike="noStrike">
-              <a:solidFill>
-                <a:schemeClr val="dk1"/>
-              </a:solidFill>
-              <a:latin typeface="Calibri"/>
-              <a:ea typeface="Calibri"/>
-              <a:cs typeface="Calibri"/>
-              <a:sym typeface="Calibri"/>
-            </a:endParaRPr>
-          </a:p>
-        </p:txBody>
-      </p:sp>
-      <p:sp>
-        <p:nvSpPr>
-          <p:cNvPr id="250" name="Google Shape;250;p20"/>
-          <p:cNvSpPr/>
-          <p:nvPr/>
-        </p:nvSpPr>
-        <p:spPr>
-          <a:xfrm>
-            <a:off x="7994451" y="4805362"/>
-            <a:ext cx="1877169" cy="9525"/>
-          </a:xfrm>
-          <a:prstGeom prst="rect">
-            <a:avLst/>
-          </a:prstGeom>
-          <a:solidFill>
-            <a:srgbClr val="E6E9E6"/>
-          </a:solidFill>
-          <a:ln>
-            <a:noFill/>
-          </a:ln>
-        </p:spPr>
-        <p:txBody>
-          <a:bodyPr anchorCtr="0" anchor="ctr" bIns="45700" lIns="91425" spcFirstLastPara="1" rIns="91425" wrap="square" tIns="45700">
-            <a:noAutofit/>
-          </a:bodyPr>
-          <a:lstStyle/>
-          <a:p>
-            <a:pPr indent="0" lvl="0" marL="0" marR="0" rtl="0" algn="ctr">
-              <a:spcBef>
-                <a:spcPts val="0"/>
-              </a:spcBef>
-              <a:spcAft>
-                <a:spcPts val="0"/>
-              </a:spcAft>
-              <a:buNone/>
-            </a:pPr>
-            <a:r>
-              <a:t/>
-            </a:r>
-            <a:endParaRPr b="0" i="0" sz="1800" u="none" cap="none" strike="noStrike">
-              <a:solidFill>
-                <a:schemeClr val="dk1"/>
-              </a:solidFill>
-              <a:latin typeface="Calibri"/>
-              <a:ea typeface="Calibri"/>
-              <a:cs typeface="Calibri"/>
-              <a:sym typeface="Calibri"/>
-            </a:endParaRPr>
-          </a:p>
-        </p:txBody>
-      </p:sp>
-      <p:sp>
-        <p:nvSpPr>
-          <p:cNvPr id="251" name="Google Shape;251;p20"/>
-          <p:cNvSpPr/>
-          <p:nvPr/>
-        </p:nvSpPr>
-        <p:spPr>
-          <a:xfrm>
-            <a:off x="9871620" y="4805362"/>
-            <a:ext cx="1748879" cy="9525"/>
-          </a:xfrm>
-          <a:prstGeom prst="rect">
-            <a:avLst/>
-          </a:prstGeom>
-          <a:solidFill>
-            <a:srgbClr val="E6E9E6"/>
-          </a:solidFill>
-          <a:ln>
-            <a:noFill/>
-          </a:ln>
-        </p:spPr>
-        <p:txBody>
-          <a:bodyPr anchorCtr="0" anchor="ctr" bIns="45700" lIns="91425" spcFirstLastPara="1" rIns="91425" wrap="square" tIns="45700">
-            <a:noAutofit/>
-          </a:bodyPr>
-          <a:lstStyle/>
-          <a:p>
-            <a:pPr indent="0" lvl="0" marL="0" marR="0" rtl="0" algn="ctr">
-              <a:spcBef>
-                <a:spcPts val="0"/>
-              </a:spcBef>
-              <a:spcAft>
-                <a:spcPts val="0"/>
-              </a:spcAft>
-              <a:buNone/>
-            </a:pPr>
-            <a:r>
-              <a:t/>
-            </a:r>
-            <a:endParaRPr b="0" i="0" sz="1800" u="none" cap="none" strike="noStrike">
-              <a:solidFill>
-                <a:schemeClr val="dk1"/>
-              </a:solidFill>
-              <a:latin typeface="Calibri"/>
-              <a:ea typeface="Calibri"/>
-              <a:cs typeface="Calibri"/>
-              <a:sym typeface="Calibri"/>
-            </a:endParaRPr>
-          </a:p>
-        </p:txBody>
-      </p:sp>
-      <p:pic>
-        <p:nvPicPr>
-          <p:cNvPr descr="image.png" id="252" name="Google Shape;252;p20"/>
-          <p:cNvPicPr preferRelativeResize="0"/>
-          <p:nvPr/>
-        </p:nvPicPr>
-        <p:blipFill rotWithShape="1">
-          <a:blip r:embed="rId4">
-            <a:alphaModFix/>
-          </a:blip>
-          <a:srcRect b="0" l="0" r="0" t="0"/>
-          <a:stretch/>
-        </p:blipFill>
-        <p:spPr>
-          <a:xfrm>
-            <a:off x="10043070" y="4171950"/>
-            <a:ext cx="123825" cy="123825"/>
-          </a:xfrm>
-          <a:prstGeom prst="rect">
-            <a:avLst/>
-          </a:prstGeom>
-          <a:noFill/>
-          <a:ln>
-            <a:noFill/>
-          </a:ln>
-        </p:spPr>
-      </p:pic>
-      <p:pic>
-        <p:nvPicPr>
-          <p:cNvPr descr="image.png" id="253" name="Google Shape;253;p20"/>
-          <p:cNvPicPr preferRelativeResize="0"/>
-          <p:nvPr/>
-        </p:nvPicPr>
-        <p:blipFill rotWithShape="1">
-          <a:blip r:embed="rId5">
-            <a:alphaModFix/>
-          </a:blip>
-          <a:srcRect b="0" l="0" r="0" t="0"/>
-          <a:stretch/>
-        </p:blipFill>
-        <p:spPr>
-          <a:xfrm>
-            <a:off x="10043070" y="3781425"/>
-            <a:ext cx="123825" cy="123825"/>
-          </a:xfrm>
-          <a:prstGeom prst="rect">
-            <a:avLst/>
-          </a:prstGeom>
-          <a:noFill/>
-          <a:ln>
-            <a:noFill/>
-          </a:ln>
-        </p:spPr>
-      </p:pic>
-      <p:pic>
-        <p:nvPicPr>
-          <p:cNvPr descr="image.png" id="254" name="Google Shape;254;p20"/>
-          <p:cNvPicPr preferRelativeResize="0"/>
-          <p:nvPr/>
-        </p:nvPicPr>
-        <p:blipFill rotWithShape="1">
-          <a:blip r:embed="rId4">
-            <a:alphaModFix/>
-          </a:blip>
-          <a:srcRect b="0" l="0" r="0" t="0"/>
-          <a:stretch/>
-        </p:blipFill>
-        <p:spPr>
-          <a:xfrm>
-            <a:off x="10043070" y="3390900"/>
-            <a:ext cx="123825" cy="123825"/>
-          </a:xfrm>
-          <a:prstGeom prst="rect">
-            <a:avLst/>
-          </a:prstGeom>
-          <a:noFill/>
-          <a:ln>
-            <a:noFill/>
-          </a:ln>
-        </p:spPr>
-      </p:pic>
-      <p:pic>
-        <p:nvPicPr>
-          <p:cNvPr descr="image.png" id="255" name="Google Shape;255;p20"/>
-          <p:cNvPicPr preferRelativeResize="0"/>
-          <p:nvPr/>
-        </p:nvPicPr>
-        <p:blipFill rotWithShape="1">
-          <a:blip r:embed="rId5">
-            <a:alphaModFix/>
-          </a:blip>
-          <a:srcRect b="0" l="0" r="0" t="0"/>
-          <a:stretch/>
-        </p:blipFill>
-        <p:spPr>
-          <a:xfrm>
-            <a:off x="10043070" y="4562475"/>
-            <a:ext cx="123825" cy="123825"/>
-          </a:xfrm>
-          <a:prstGeom prst="rect">
-            <a:avLst/>
-          </a:prstGeom>
-          <a:noFill/>
-          <a:ln>
-            <a:noFill/>
-          </a:ln>
-        </p:spPr>
-      </p:pic>
-      <p:pic>
-        <p:nvPicPr>
-          <p:cNvPr descr="image.png" id="256" name="Google Shape;256;p20"/>
-          <p:cNvPicPr preferRelativeResize="0"/>
-          <p:nvPr/>
-        </p:nvPicPr>
-        <p:blipFill rotWithShape="1">
-          <a:blip r:embed="rId4">
-            <a:alphaModFix/>
-          </a:blip>
-          <a:srcRect b="0" l="0" r="0" t="0"/>
-          <a:stretch/>
-        </p:blipFill>
-        <p:spPr>
-          <a:xfrm>
-            <a:off x="10043070" y="3390900"/>
-            <a:ext cx="123825" cy="123825"/>
-          </a:xfrm>
-          <a:prstGeom prst="rect">
-            <a:avLst/>
-          </a:prstGeom>
-          <a:noFill/>
-          <a:ln>
-            <a:noFill/>
-          </a:ln>
-        </p:spPr>
-      </p:pic>
-      <p:pic>
-        <p:nvPicPr>
-          <p:cNvPr descr="image.png" id="257" name="Google Shape;257;p20"/>
-          <p:cNvPicPr preferRelativeResize="0"/>
-          <p:nvPr/>
-        </p:nvPicPr>
-        <p:blipFill rotWithShape="1">
-          <a:blip r:embed="rId5">
-            <a:alphaModFix/>
-          </a:blip>
-          <a:srcRect b="0" l="0" r="0" t="0"/>
-          <a:stretch/>
-        </p:blipFill>
-        <p:spPr>
-          <a:xfrm>
-            <a:off x="10043070" y="3781425"/>
-            <a:ext cx="123825" cy="123825"/>
-          </a:xfrm>
-          <a:prstGeom prst="rect">
-            <a:avLst/>
-          </a:prstGeom>
-          <a:noFill/>
-          <a:ln>
-            <a:noFill/>
-          </a:ln>
-        </p:spPr>
-      </p:pic>
-      <p:pic>
-        <p:nvPicPr>
-          <p:cNvPr descr="image.png" id="258" name="Google Shape;258;p20"/>
-          <p:cNvPicPr preferRelativeResize="0"/>
-          <p:nvPr/>
-        </p:nvPicPr>
-        <p:blipFill rotWithShape="1">
-          <a:blip r:embed="rId4">
-            <a:alphaModFix/>
-          </a:blip>
-          <a:srcRect b="0" l="0" r="0" t="0"/>
-          <a:stretch/>
-        </p:blipFill>
-        <p:spPr>
-          <a:xfrm>
-            <a:off x="10043070" y="4171950"/>
-            <a:ext cx="123825" cy="123825"/>
-          </a:xfrm>
-          <a:prstGeom prst="rect">
-            <a:avLst/>
-          </a:prstGeom>
-          <a:noFill/>
-          <a:ln>
-            <a:noFill/>
-          </a:ln>
-        </p:spPr>
-      </p:pic>
-      <p:pic>
-        <p:nvPicPr>
-          <p:cNvPr descr="image.png" id="259" name="Google Shape;259;p20"/>
-          <p:cNvPicPr preferRelativeResize="0"/>
-          <p:nvPr/>
-        </p:nvPicPr>
-        <p:blipFill rotWithShape="1">
-          <a:blip r:embed="rId5">
-            <a:alphaModFix/>
-          </a:blip>
-          <a:srcRect b="0" l="0" r="0" t="0"/>
-          <a:stretch/>
-        </p:blipFill>
-        <p:spPr>
-          <a:xfrm>
-            <a:off x="10043070" y="4562475"/>
-            <a:ext cx="123825" cy="123825"/>
-          </a:xfrm>
-          <a:prstGeom prst="rect">
-            <a:avLst/>
-          </a:prstGeom>
-          <a:noFill/>
-          <a:ln>
-            <a:noFill/>
-          </a:ln>
-        </p:spPr>
-      </p:pic>
       <p:sp>
         <p:nvSpPr>
           <p:cNvPr id="260" name="Google Shape;260;p20"/>
@@ -20994,57 +16875,30 @@
           </a:p>
         </p:txBody>
       </p:sp>
-      <p:sp>
-        <p:nvSpPr>
-          <p:cNvPr id="261" name="Google Shape;261;p20"/>
-          <p:cNvSpPr/>
-          <p:nvPr/>
-        </p:nvSpPr>
-        <p:spPr>
-          <a:xfrm>
-            <a:off x="571500" y="981075"/>
-            <a:ext cx="11049000" cy="19050"/>
-          </a:xfrm>
-          <a:prstGeom prst="rect">
-            <a:avLst/>
-          </a:prstGeom>
-          <a:solidFill>
-            <a:srgbClr val="C59B27"/>
-          </a:solidFill>
-          <a:ln>
-            <a:noFill/>
-          </a:ln>
-        </p:spPr>
-        <p:txBody>
-          <a:bodyPr anchorCtr="0" anchor="ctr" bIns="45700" lIns="91425" spcFirstLastPara="1" rIns="91425" wrap="square" tIns="45700">
-            <a:noAutofit/>
-          </a:bodyPr>
-          <a:lstStyle/>
-          <a:p>
-            <a:pPr indent="0" lvl="0" marL="0" marR="0" rtl="0" algn="ctr">
-              <a:spcBef>
-                <a:spcPts val="0"/>
-              </a:spcBef>
-              <a:spcAft>
-                <a:spcPts val="0"/>
-              </a:spcAft>
-              <a:buNone/>
-            </a:pPr>
-            <a:r>
-              <a:t/>
-            </a:r>
-            <a:endParaRPr b="0" i="0" sz="1800" u="none" cap="none" strike="noStrike">
-              <a:solidFill>
-                <a:schemeClr val="dk1"/>
-              </a:solidFill>
-              <a:latin typeface="Calibri"/>
-              <a:ea typeface="Calibri"/>
-              <a:cs typeface="Calibri"/>
-              <a:sym typeface="Calibri"/>
-            </a:endParaRPr>
-          </a:p>
-        </p:txBody>
-      </p:sp>
+      <p:pic>
+        <p:nvPicPr>
+          <p:cNvPr id="261" name="Picture 260" descr="image_1779630681661.png"/>
+          <p:cNvPicPr>
+            <a:picLocks noChangeAspect="1"/>
+          </p:cNvPicPr>
+          <p:nvPr/>
+        </p:nvPicPr>
+        <p:blipFill>
+          <a:blip r:embed="rId6"/>
+          <a:stretch>
+            <a:fillRect/>
+          </a:stretch>
+        </p:blipFill>
+        <p:spPr>
+          <a:xfrm>
+            <a:off x="502920" y="1463040"/>
+            <a:ext cx="11183112" cy="4937760"/>
+          </a:xfrm>
+          <a:prstGeom prst="rect">
+            <a:avLst/>
+          </a:prstGeom>
+        </p:spPr>
+      </p:pic>
     </p:spTree>
   </p:cSld>
   <p:clrMapOvr>

</xml_diff>